<commit_message>
slides: añadir guía paso a paso de uso y actualizar autores
Nueva diapositiva "Cómo usar la app" con pasos guiados y enlaces
clicables (Python, app local, App Password de Google). Reemplaza
"Hibrusi" por "Javier, David y Bruno" en footers y portada.

Co-Authored-By: Claude Opus 4.7 (1M context) <noreply@anthropic.com>
</commit_message>
<xml_diff>
--- a/presentacion.pptx
+++ b/presentacion.pptx
@@ -13,6 +13,7 @@
     <p:sldId id="261" r:id="rId7"/>
     <p:sldId id="262" r:id="rId8"/>
     <p:sldId id="263" r:id="rId9"/>
+    <p:sldId id="267" r:id="rId18"/>
     <p:sldId id="264" r:id="rId10"/>
     <p:sldId id="265" r:id="rId11"/>
     <p:sldId id="266" r:id="rId12"/>
@@ -2128,6 +2129,10 @@
             <a:prstDash val="solid"/>
           </a:ln>
         </p:spPr>
+        <p:txBody>
+          <a:bodyPr/>
+          <a:p/>
+        </p:txBody>
       </p:sp>
       <p:sp>
         <p:nvSpPr>
@@ -2153,6 +2158,10 @@
             <a:prstDash val="solid"/>
           </a:ln>
         </p:spPr>
+        <p:txBody>
+          <a:bodyPr/>
+          <a:p/>
+        </p:txBody>
       </p:sp>
       <p:sp>
         <p:nvSpPr>
@@ -2180,6 +2189,10 @@
             <a:prstDash val="solid"/>
           </a:ln>
         </p:spPr>
+        <p:txBody>
+          <a:bodyPr/>
+          <a:p/>
+        </p:txBody>
       </p:sp>
       <p:sp>
         <p:nvSpPr>
@@ -2389,6 +2402,10 @@
             <a:prstDash val="solid"/>
           </a:ln>
         </p:spPr>
+        <p:txBody>
+          <a:bodyPr/>
+          <a:p/>
+        </p:txBody>
       </p:sp>
       <p:sp>
         <p:nvSpPr>
@@ -2423,7 +2440,7 @@
                 <a:ea typeface="Calibri" pitchFamily="34" charset="-122"/>
                 <a:cs typeface="Calibri" pitchFamily="34" charset="-120"/>
               </a:rPr>
-              <a:t>Bruno</a:t>
+              <a:t>Javier, David y Bruno</a:t>
             </a:r>
             <a:endParaRPr lang="en-US" sz="1300" dirty="0"/>
           </a:p>
@@ -2455,6 +2472,669 @@
 </file>
 
 <file path=ppt/slides/slide10.xml><?xml version="1.0" encoding="utf-8"?>
+<p:sld xmlns:a="http://schemas.openxmlformats.org/drawingml/2006/main" xmlns:r="http://schemas.openxmlformats.org/officeDocument/2006/relationships" xmlns:p="http://schemas.openxmlformats.org/presentationml/2006/main">
+  <p:cSld name="Slide 9">
+    <p:bg>
+      <p:bgPr>
+        <a:solidFill>
+          <a:srgbClr val="FFFFFF"/>
+        </a:solidFill>
+      </p:bgPr>
+    </p:bg>
+    <p:spTree>
+      <p:nvGrpSpPr>
+        <p:cNvPr id="1" name=""/>
+        <p:cNvGrpSpPr/>
+        <p:nvPr/>
+      </p:nvGrpSpPr>
+      <p:grpSpPr>
+        <a:xfrm>
+          <a:off x="0" y="0"/>
+          <a:ext cx="0" cy="0"/>
+          <a:chOff x="0" y="0"/>
+          <a:chExt cx="0" cy="0"/>
+        </a:xfrm>
+      </p:grpSpPr>
+      <p:sp>
+        <p:nvSpPr>
+          <p:cNvPr id="2" name="Text 0"/>
+          <p:cNvSpPr/>
+          <p:nvPr/>
+        </p:nvSpPr>
+        <p:spPr>
+          <a:xfrm>
+            <a:off x="457200" y="365760"/>
+            <a:ext cx="8229600" cy="640080"/>
+          </a:xfrm>
+          <a:prstGeom prst="rect">
+            <a:avLst/>
+          </a:prstGeom>
+          <a:noFill/>
+          <a:ln/>
+        </p:spPr>
+        <p:txBody>
+          <a:bodyPr wrap="square" lIns="0" tIns="0" rIns="0" bIns="0" rtlCol="0" anchor="ctr"/>
+          <a:lstStyle/>
+          <a:p>
+            <a:pPr indent="0" marL="0">
+              <a:buNone/>
+            </a:pPr>
+            <a:r>
+              <a:rPr lang="en-US" sz="3000" b="1" dirty="0">
+                <a:solidFill>
+                  <a:srgbClr val="1A2C52"/>
+                </a:solidFill>
+                <a:latin typeface="Calibri" pitchFamily="34" charset="0"/>
+                <a:ea typeface="Calibri" pitchFamily="34" charset="-122"/>
+                <a:cs typeface="Calibri" pitchFamily="34" charset="-120"/>
+              </a:rPr>
+              <a:t>Manual vs. automatizado</a:t>
+            </a:r>
+            <a:endParaRPr lang="en-US" sz="3000" dirty="0"/>
+          </a:p>
+        </p:txBody>
+      </p:sp>
+      <p:sp>
+        <p:nvSpPr>
+          <p:cNvPr id="3" name="Text 1"/>
+          <p:cNvSpPr/>
+          <p:nvPr/>
+        </p:nvSpPr>
+        <p:spPr>
+          <a:xfrm>
+            <a:off x="457200" y="960120"/>
+            <a:ext cx="8229600" cy="320040"/>
+          </a:xfrm>
+          <a:prstGeom prst="rect">
+            <a:avLst/>
+          </a:prstGeom>
+          <a:noFill/>
+          <a:ln/>
+        </p:spPr>
+        <p:txBody>
+          <a:bodyPr wrap="square" lIns="0" tIns="0" rIns="0" bIns="0" rtlCol="0" anchor="ctr"/>
+          <a:lstStyle/>
+          <a:p>
+            <a:pPr indent="0" marL="0">
+              <a:buNone/>
+            </a:pPr>
+            <a:r>
+              <a:rPr lang="en-US" sz="1400" i="1" dirty="0">
+                <a:solidFill>
+                  <a:srgbClr val="475569"/>
+                </a:solidFill>
+                <a:latin typeface="Calibri" pitchFamily="34" charset="0"/>
+                <a:ea typeface="Calibri" pitchFamily="34" charset="-122"/>
+                <a:cs typeface="Calibri" pitchFamily="34" charset="-120"/>
+              </a:rPr>
+              <a:t>Comparativa de tiempo de ejecución y otros indicadores</a:t>
+            </a:r>
+            <a:endParaRPr lang="en-US" sz="1400" dirty="0"/>
+          </a:p>
+        </p:txBody>
+      </p:sp>
+      <p:graphicFrame>
+        <p:nvGraphicFramePr>
+          <p:cNvPr id="4" name="Chart 0" descr=""/>
+          <p:cNvGraphicFramePr/>
+          <p:nvPr/>
+        </p:nvGraphicFramePr>
+        <p:xfrm>
+          <a:off x="457200" y="1417320"/>
+          <a:ext cx="5029200" cy="3200400"/>
+        </p:xfrm>
+        <a:graphic xmlns:a="http://schemas.openxmlformats.org/drawingml/2006/main">
+          <a:graphicData uri="http://schemas.openxmlformats.org/drawingml/2006/chart">
+            <c:chart xmlns:c="http://schemas.openxmlformats.org/drawingml/2006/chart" r:id="rId1"/>
+          </a:graphicData>
+        </a:graphic>
+      </p:graphicFrame>
+      <p:sp>
+        <p:nvSpPr>
+          <p:cNvPr id="5" name="Shape 2"/>
+          <p:cNvSpPr/>
+          <p:nvPr/>
+        </p:nvSpPr>
+        <p:spPr>
+          <a:xfrm>
+            <a:off x="5852160" y="1463040"/>
+            <a:ext cx="2834640" cy="914400"/>
+          </a:xfrm>
+          <a:prstGeom prst="rect">
+            <a:avLst/>
+          </a:prstGeom>
+          <a:solidFill>
+            <a:srgbClr val="EEF4FF"/>
+          </a:solidFill>
+          <a:ln w="12700">
+            <a:solidFill>
+              <a:srgbClr val="B8C8E8"/>
+            </a:solidFill>
+            <a:prstDash val="solid"/>
+          </a:ln>
+        </p:spPr>
+        <p:txBody>
+          <a:bodyPr/>
+          <a:p/>
+        </p:txBody>
+      </p:sp>
+      <p:sp>
+        <p:nvSpPr>
+          <p:cNvPr id="6" name="Shape 3"/>
+          <p:cNvSpPr/>
+          <p:nvPr/>
+        </p:nvSpPr>
+        <p:spPr>
+          <a:xfrm>
+            <a:off x="5852160" y="1463040"/>
+            <a:ext cx="73152" cy="914400"/>
+          </a:xfrm>
+          <a:prstGeom prst="rect">
+            <a:avLst/>
+          </a:prstGeom>
+          <a:solidFill>
+            <a:srgbClr val="FF7A18"/>
+          </a:solidFill>
+          <a:ln w="12700">
+            <a:solidFill>
+              <a:srgbClr val="FF7A18"/>
+            </a:solidFill>
+            <a:prstDash val="solid"/>
+          </a:ln>
+        </p:spPr>
+        <p:txBody>
+          <a:bodyPr/>
+          <a:p/>
+        </p:txBody>
+      </p:sp>
+      <p:sp>
+        <p:nvSpPr>
+          <p:cNvPr id="7" name="Text 4"/>
+          <p:cNvSpPr/>
+          <p:nvPr/>
+        </p:nvSpPr>
+        <p:spPr>
+          <a:xfrm>
+            <a:off x="6035040" y="1508760"/>
+            <a:ext cx="1371600" cy="502920"/>
+          </a:xfrm>
+          <a:prstGeom prst="rect">
+            <a:avLst/>
+          </a:prstGeom>
+          <a:noFill/>
+          <a:ln/>
+        </p:spPr>
+        <p:txBody>
+          <a:bodyPr wrap="square" lIns="0" tIns="0" rIns="0" bIns="0" rtlCol="0" anchor="ctr"/>
+          <a:lstStyle/>
+          <a:p>
+            <a:pPr indent="0" marL="0">
+              <a:buNone/>
+            </a:pPr>
+            <a:r>
+              <a:rPr lang="en-US" sz="3000" b="1" dirty="0">
+                <a:solidFill>
+                  <a:srgbClr val="1A2C52"/>
+                </a:solidFill>
+                <a:latin typeface="Georgia" pitchFamily="34" charset="0"/>
+                <a:ea typeface="Georgia" pitchFamily="34" charset="-122"/>
+                <a:cs typeface="Georgia" pitchFamily="34" charset="-120"/>
+              </a:rPr>
+              <a:t>80×</a:t>
+            </a:r>
+            <a:endParaRPr lang="en-US" sz="3000" dirty="0"/>
+          </a:p>
+        </p:txBody>
+      </p:sp>
+      <p:sp>
+        <p:nvSpPr>
+          <p:cNvPr id="8" name="Text 5"/>
+          <p:cNvSpPr/>
+          <p:nvPr/>
+        </p:nvSpPr>
+        <p:spPr>
+          <a:xfrm>
+            <a:off x="7406640" y="1600200"/>
+            <a:ext cx="1188720" cy="685800"/>
+          </a:xfrm>
+          <a:prstGeom prst="rect">
+            <a:avLst/>
+          </a:prstGeom>
+          <a:noFill/>
+          <a:ln/>
+        </p:spPr>
+        <p:txBody>
+          <a:bodyPr wrap="square" lIns="0" tIns="0" rIns="0" bIns="0" rtlCol="0" anchor="ctr"/>
+          <a:lstStyle/>
+          <a:p>
+            <a:pPr indent="0" marL="0">
+              <a:buNone/>
+            </a:pPr>
+            <a:r>
+              <a:rPr lang="en-US" sz="1050" b="1" dirty="0">
+                <a:solidFill>
+                  <a:srgbClr val="1A2C52"/>
+                </a:solidFill>
+                <a:latin typeface="Calibri" pitchFamily="34" charset="0"/>
+                <a:ea typeface="Calibri" pitchFamily="34" charset="-122"/>
+                <a:cs typeface="Calibri" pitchFamily="34" charset="-120"/>
+              </a:rPr>
+              <a:t>más rápido</a:t>
+            </a:r>
+            <a:endParaRPr lang="en-US" sz="1050" dirty="0"/>
+          </a:p>
+          <a:p>
+            <a:pPr indent="0" marL="0">
+              <a:buNone/>
+            </a:pPr>
+            <a:r>
+              <a:rPr lang="en-US" sz="900" dirty="0">
+                <a:solidFill>
+                  <a:srgbClr val="475569"/>
+                </a:solidFill>
+                <a:latin typeface="Calibri" pitchFamily="34" charset="0"/>
+                <a:ea typeface="Calibri" pitchFamily="34" charset="-122"/>
+                <a:cs typeface="Calibri" pitchFamily="34" charset="-120"/>
+              </a:rPr>
+              <a:t>20 min → 15 seg</a:t>
+            </a:r>
+            <a:endParaRPr lang="en-US" sz="1050" dirty="0"/>
+          </a:p>
+        </p:txBody>
+      </p:sp>
+      <p:sp>
+        <p:nvSpPr>
+          <p:cNvPr id="9" name="Shape 6"/>
+          <p:cNvSpPr/>
+          <p:nvPr/>
+        </p:nvSpPr>
+        <p:spPr>
+          <a:xfrm>
+            <a:off x="5852160" y="2542032"/>
+            <a:ext cx="2834640" cy="914400"/>
+          </a:xfrm>
+          <a:prstGeom prst="rect">
+            <a:avLst/>
+          </a:prstGeom>
+          <a:solidFill>
+            <a:srgbClr val="EEF4FF"/>
+          </a:solidFill>
+          <a:ln w="12700">
+            <a:solidFill>
+              <a:srgbClr val="B8C8E8"/>
+            </a:solidFill>
+            <a:prstDash val="solid"/>
+          </a:ln>
+        </p:spPr>
+        <p:txBody>
+          <a:bodyPr/>
+          <a:p/>
+        </p:txBody>
+      </p:sp>
+      <p:sp>
+        <p:nvSpPr>
+          <p:cNvPr id="10" name="Shape 7"/>
+          <p:cNvSpPr/>
+          <p:nvPr/>
+        </p:nvSpPr>
+        <p:spPr>
+          <a:xfrm>
+            <a:off x="5852160" y="2542032"/>
+            <a:ext cx="73152" cy="914400"/>
+          </a:xfrm>
+          <a:prstGeom prst="rect">
+            <a:avLst/>
+          </a:prstGeom>
+          <a:solidFill>
+            <a:srgbClr val="FF7A18"/>
+          </a:solidFill>
+          <a:ln w="12700">
+            <a:solidFill>
+              <a:srgbClr val="FF7A18"/>
+            </a:solidFill>
+            <a:prstDash val="solid"/>
+          </a:ln>
+        </p:spPr>
+        <p:txBody>
+          <a:bodyPr/>
+          <a:p/>
+        </p:txBody>
+      </p:sp>
+      <p:sp>
+        <p:nvSpPr>
+          <p:cNvPr id="11" name="Text 8"/>
+          <p:cNvSpPr/>
+          <p:nvPr/>
+        </p:nvSpPr>
+        <p:spPr>
+          <a:xfrm>
+            <a:off x="6035040" y="2587752"/>
+            <a:ext cx="1371600" cy="502920"/>
+          </a:xfrm>
+          <a:prstGeom prst="rect">
+            <a:avLst/>
+          </a:prstGeom>
+          <a:noFill/>
+          <a:ln/>
+        </p:spPr>
+        <p:txBody>
+          <a:bodyPr wrap="square" lIns="0" tIns="0" rIns="0" bIns="0" rtlCol="0" anchor="ctr"/>
+          <a:lstStyle/>
+          <a:p>
+            <a:pPr indent="0" marL="0">
+              <a:buNone/>
+            </a:pPr>
+            <a:r>
+              <a:rPr lang="en-US" sz="3000" b="1" dirty="0">
+                <a:solidFill>
+                  <a:srgbClr val="1A2C52"/>
+                </a:solidFill>
+                <a:latin typeface="Georgia" pitchFamily="34" charset="0"/>
+                <a:ea typeface="Georgia" pitchFamily="34" charset="-122"/>
+                <a:cs typeface="Georgia" pitchFamily="34" charset="-120"/>
+              </a:rPr>
+              <a:t>0%</a:t>
+            </a:r>
+            <a:endParaRPr lang="en-US" sz="3000" dirty="0"/>
+          </a:p>
+        </p:txBody>
+      </p:sp>
+      <p:sp>
+        <p:nvSpPr>
+          <p:cNvPr id="12" name="Text 9"/>
+          <p:cNvSpPr/>
+          <p:nvPr/>
+        </p:nvSpPr>
+        <p:spPr>
+          <a:xfrm>
+            <a:off x="7406640" y="2679192"/>
+            <a:ext cx="1188720" cy="685800"/>
+          </a:xfrm>
+          <a:prstGeom prst="rect">
+            <a:avLst/>
+          </a:prstGeom>
+          <a:noFill/>
+          <a:ln/>
+        </p:spPr>
+        <p:txBody>
+          <a:bodyPr wrap="square" lIns="0" tIns="0" rIns="0" bIns="0" rtlCol="0" anchor="ctr"/>
+          <a:lstStyle/>
+          <a:p>
+            <a:pPr indent="0" marL="0">
+              <a:buNone/>
+            </a:pPr>
+            <a:r>
+              <a:rPr lang="en-US" sz="1050" b="1" dirty="0">
+                <a:solidFill>
+                  <a:srgbClr val="1A2C52"/>
+                </a:solidFill>
+                <a:latin typeface="Calibri" pitchFamily="34" charset="0"/>
+                <a:ea typeface="Calibri" pitchFamily="34" charset="-122"/>
+                <a:cs typeface="Calibri" pitchFamily="34" charset="-120"/>
+              </a:rPr>
+              <a:t>tasa de error</a:t>
+            </a:r>
+            <a:endParaRPr lang="en-US" sz="1050" dirty="0"/>
+          </a:p>
+          <a:p>
+            <a:pPr indent="0" marL="0">
+              <a:buNone/>
+            </a:pPr>
+            <a:r>
+              <a:rPr lang="en-US" sz="900" dirty="0">
+                <a:solidFill>
+                  <a:srgbClr val="475569"/>
+                </a:solidFill>
+                <a:latin typeface="Calibri" pitchFamily="34" charset="0"/>
+                <a:ea typeface="Calibri" pitchFamily="34" charset="-122"/>
+                <a:cs typeface="Calibri" pitchFamily="34" charset="-120"/>
+              </a:rPr>
+              <a:t>vs. 5–10% manual</a:t>
+            </a:r>
+            <a:endParaRPr lang="en-US" sz="1050" dirty="0"/>
+          </a:p>
+        </p:txBody>
+      </p:sp>
+      <p:sp>
+        <p:nvSpPr>
+          <p:cNvPr id="13" name="Shape 10"/>
+          <p:cNvSpPr/>
+          <p:nvPr/>
+        </p:nvSpPr>
+        <p:spPr>
+          <a:xfrm>
+            <a:off x="5852160" y="3621024"/>
+            <a:ext cx="2834640" cy="914400"/>
+          </a:xfrm>
+          <a:prstGeom prst="rect">
+            <a:avLst/>
+          </a:prstGeom>
+          <a:solidFill>
+            <a:srgbClr val="EEF4FF"/>
+          </a:solidFill>
+          <a:ln w="12700">
+            <a:solidFill>
+              <a:srgbClr val="B8C8E8"/>
+            </a:solidFill>
+            <a:prstDash val="solid"/>
+          </a:ln>
+        </p:spPr>
+        <p:txBody>
+          <a:bodyPr/>
+          <a:p/>
+        </p:txBody>
+      </p:sp>
+      <p:sp>
+        <p:nvSpPr>
+          <p:cNvPr id="14" name="Shape 11"/>
+          <p:cNvSpPr/>
+          <p:nvPr/>
+        </p:nvSpPr>
+        <p:spPr>
+          <a:xfrm>
+            <a:off x="5852160" y="3621024"/>
+            <a:ext cx="73152" cy="914400"/>
+          </a:xfrm>
+          <a:prstGeom prst="rect">
+            <a:avLst/>
+          </a:prstGeom>
+          <a:solidFill>
+            <a:srgbClr val="FF7A18"/>
+          </a:solidFill>
+          <a:ln w="12700">
+            <a:solidFill>
+              <a:srgbClr val="FF7A18"/>
+            </a:solidFill>
+            <a:prstDash val="solid"/>
+          </a:ln>
+        </p:spPr>
+        <p:txBody>
+          <a:bodyPr/>
+          <a:p/>
+        </p:txBody>
+      </p:sp>
+      <p:sp>
+        <p:nvSpPr>
+          <p:cNvPr id="15" name="Text 12"/>
+          <p:cNvSpPr/>
+          <p:nvPr/>
+        </p:nvSpPr>
+        <p:spPr>
+          <a:xfrm>
+            <a:off x="6035040" y="3666744"/>
+            <a:ext cx="1371600" cy="502920"/>
+          </a:xfrm>
+          <a:prstGeom prst="rect">
+            <a:avLst/>
+          </a:prstGeom>
+          <a:noFill/>
+          <a:ln/>
+        </p:spPr>
+        <p:txBody>
+          <a:bodyPr wrap="square" lIns="0" tIns="0" rIns="0" bIns="0" rtlCol="0" anchor="ctr"/>
+          <a:lstStyle/>
+          <a:p>
+            <a:pPr indent="0" marL="0">
+              <a:buNone/>
+            </a:pPr>
+            <a:r>
+              <a:rPr lang="en-US" sz="3000" b="1" dirty="0">
+                <a:solidFill>
+                  <a:srgbClr val="1A2C52"/>
+                </a:solidFill>
+                <a:latin typeface="Georgia" pitchFamily="34" charset="0"/>
+                <a:ea typeface="Georgia" pitchFamily="34" charset="-122"/>
+                <a:cs typeface="Georgia" pitchFamily="34" charset="-120"/>
+              </a:rPr>
+              <a:t>+3</a:t>
+            </a:r>
+            <a:endParaRPr lang="en-US" sz="3000" dirty="0"/>
+          </a:p>
+        </p:txBody>
+      </p:sp>
+      <p:sp>
+        <p:nvSpPr>
+          <p:cNvPr id="16" name="Text 13"/>
+          <p:cNvSpPr/>
+          <p:nvPr/>
+        </p:nvSpPr>
+        <p:spPr>
+          <a:xfrm>
+            <a:off x="7406640" y="3758184"/>
+            <a:ext cx="1188720" cy="685800"/>
+          </a:xfrm>
+          <a:prstGeom prst="rect">
+            <a:avLst/>
+          </a:prstGeom>
+          <a:noFill/>
+          <a:ln/>
+        </p:spPr>
+        <p:txBody>
+          <a:bodyPr wrap="square" lIns="0" tIns="0" rIns="0" bIns="0" rtlCol="0" anchor="ctr"/>
+          <a:lstStyle/>
+          <a:p>
+            <a:pPr indent="0" marL="0">
+              <a:buNone/>
+            </a:pPr>
+            <a:r>
+              <a:rPr lang="en-US" sz="1050" b="1" dirty="0">
+                <a:solidFill>
+                  <a:srgbClr val="1A2C52"/>
+                </a:solidFill>
+                <a:latin typeface="Calibri" pitchFamily="34" charset="0"/>
+                <a:ea typeface="Calibri" pitchFamily="34" charset="-122"/>
+                <a:cs typeface="Calibri" pitchFamily="34" charset="-120"/>
+              </a:rPr>
+              <a:t>ciudades cubiertas</a:t>
+            </a:r>
+            <a:endParaRPr lang="en-US" sz="1050" dirty="0"/>
+          </a:p>
+          <a:p>
+            <a:pPr indent="0" marL="0">
+              <a:buNone/>
+            </a:pPr>
+            <a:r>
+              <a:rPr lang="en-US" sz="900" dirty="0">
+                <a:solidFill>
+                  <a:srgbClr val="475569"/>
+                </a:solidFill>
+                <a:latin typeface="Calibri" pitchFamily="34" charset="0"/>
+                <a:ea typeface="Calibri" pitchFamily="34" charset="-122"/>
+                <a:cs typeface="Calibri" pitchFamily="34" charset="-120"/>
+              </a:rPr>
+              <a:t>sin coste extra</a:t>
+            </a:r>
+            <a:endParaRPr lang="en-US" sz="1050" dirty="0"/>
+          </a:p>
+        </p:txBody>
+      </p:sp>
+      <p:sp>
+        <p:nvSpPr>
+          <p:cNvPr id="17" name="Text 14"/>
+          <p:cNvSpPr/>
+          <p:nvPr/>
+        </p:nvSpPr>
+        <p:spPr>
+          <a:xfrm>
+            <a:off x="457200" y="4800600"/>
+            <a:ext cx="5486400" cy="274320"/>
+          </a:xfrm>
+          <a:prstGeom prst="rect">
+            <a:avLst/>
+          </a:prstGeom>
+          <a:noFill/>
+          <a:ln/>
+        </p:spPr>
+        <p:txBody>
+          <a:bodyPr wrap="square" rtlCol="0" anchor="ctr"/>
+          <a:lstStyle/>
+          <a:p>
+            <a:pPr indent="0" marL="0">
+              <a:buNone/>
+            </a:pPr>
+            <a:r>
+              <a:rPr lang="en-US" sz="900" dirty="0">
+                <a:solidFill>
+                  <a:srgbClr val="475569"/>
+                </a:solidFill>
+                <a:latin typeface="Calibri" pitchFamily="34" charset="0"/>
+                <a:ea typeface="Calibri" pitchFamily="34" charset="-122"/>
+                <a:cs typeface="Calibri" pitchFamily="34" charset="-120"/>
+              </a:rPr>
+              <a:t>Javier, David y Bruno · Automatización · Proyecto Nebrija</a:t>
+            </a:r>
+            <a:endParaRPr lang="en-US" sz="900" dirty="0"/>
+          </a:p>
+        </p:txBody>
+      </p:sp>
+      <p:sp>
+        <p:nvSpPr>
+          <p:cNvPr id="18" name="Text 15"/>
+          <p:cNvSpPr/>
+          <p:nvPr/>
+        </p:nvSpPr>
+        <p:spPr>
+          <a:xfrm>
+            <a:off x="8412480" y="4800600"/>
+            <a:ext cx="457200" cy="274320"/>
+          </a:xfrm>
+          <a:prstGeom prst="rect">
+            <a:avLst/>
+          </a:prstGeom>
+          <a:noFill/>
+          <a:ln/>
+        </p:spPr>
+        <p:txBody>
+          <a:bodyPr wrap="square" rtlCol="0" anchor="ctr"/>
+          <a:lstStyle/>
+          <a:p>
+            <a:pPr algn="r" indent="0" marL="0">
+              <a:buNone/>
+            </a:pPr>
+            <a:r>
+              <a:rPr lang="en-US" sz="900" dirty="0">
+                <a:solidFill>
+                  <a:srgbClr val="475569"/>
+                </a:solidFill>
+                <a:latin typeface="Calibri" pitchFamily="34" charset="0"/>
+                <a:ea typeface="Calibri" pitchFamily="34" charset="-122"/>
+                <a:cs typeface="Calibri" pitchFamily="34" charset="-120"/>
+              </a:rPr>
+              <a:t>10</a:t>
+            </a:r>
+            <a:endParaRPr lang="en-US" sz="900" dirty="0"/>
+          </a:p>
+        </p:txBody>
+      </p:sp>
+    </p:spTree>
+  </p:cSld>
+  <p:clrMapOvr>
+    <a:masterClrMapping/>
+  </p:clrMapOvr>
+</p:sld>
+</file>
+
+<file path=ppt/slides/slide11.xml><?xml version="1.0" encoding="utf-8"?>
 <p:sld xmlns:a="http://schemas.openxmlformats.org/drawingml/2006/main" xmlns:r="http://schemas.openxmlformats.org/officeDocument/2006/relationships" xmlns:p="http://schemas.openxmlformats.org/presentationml/2006/main">
   <p:cSld name="Slide 10">
     <p:bg>
@@ -2580,6 +3260,10 @@
             <a:prstDash val="solid"/>
           </a:ln>
         </p:spPr>
+        <p:txBody>
+          <a:bodyPr/>
+          <a:p/>
+        </p:txBody>
       </p:sp>
       <p:pic>
         <p:nvPicPr>
@@ -2774,6 +3458,10 @@
             <a:prstDash val="solid"/>
           </a:ln>
         </p:spPr>
+        <p:txBody>
+          <a:bodyPr/>
+          <a:p/>
+        </p:txBody>
       </p:sp>
       <p:pic>
         <p:nvPicPr>
@@ -2977,7 +3665,7 @@
                 <a:ea typeface="Calibri" pitchFamily="34" charset="-122"/>
                 <a:cs typeface="Calibri" pitchFamily="34" charset="-120"/>
               </a:rPr>
-              <a:t>Hibrusi · Automatización · Proyecto Nebrija</a:t>
+              <a:t>Javier, David y Bruno · Automatización · Proyecto Nebrija</a:t>
             </a:r>
             <a:endParaRPr lang="en-US" sz="900" dirty="0"/>
           </a:p>
@@ -3016,7 +3704,7 @@
                 <a:ea typeface="Calibri" pitchFamily="34" charset="-122"/>
                 <a:cs typeface="Calibri" pitchFamily="34" charset="-120"/>
               </a:rPr>
-              <a:t>10</a:t>
+              <a:t>11</a:t>
             </a:r>
             <a:endParaRPr lang="en-US" sz="900" dirty="0"/>
           </a:p>
@@ -3030,7 +3718,7 @@
 </p:sld>
 </file>
 
-<file path=ppt/slides/slide11.xml><?xml version="1.0" encoding="utf-8"?>
+<file path=ppt/slides/slide12.xml><?xml version="1.0" encoding="utf-8"?>
 <p:sld xmlns:a="http://schemas.openxmlformats.org/drawingml/2006/main" xmlns:r="http://schemas.openxmlformats.org/officeDocument/2006/relationships" xmlns:p="http://schemas.openxmlformats.org/presentationml/2006/main">
   <p:cSld name="Slide 11">
     <p:bg>
@@ -3078,6 +3766,10 @@
             <a:prstDash val="solid"/>
           </a:ln>
         </p:spPr>
+        <p:txBody>
+          <a:bodyPr/>
+          <a:p/>
+        </p:txBody>
       </p:sp>
       <p:sp>
         <p:nvSpPr>
@@ -3103,6 +3795,10 @@
             <a:prstDash val="solid"/>
           </a:ln>
         </p:spPr>
+        <p:txBody>
+          <a:bodyPr/>
+          <a:p/>
+        </p:txBody>
       </p:sp>
       <p:sp>
         <p:nvSpPr>
@@ -3262,6 +3958,10 @@
             <a:prstDash val="solid"/>
           </a:ln>
         </p:spPr>
+        <p:txBody>
+          <a:bodyPr/>
+          <a:p/>
+        </p:txBody>
       </p:sp>
       <p:sp>
         <p:nvSpPr>
@@ -3453,6 +4153,10 @@
             <a:prstDash val="solid"/>
           </a:ln>
         </p:spPr>
+        <p:txBody>
+          <a:bodyPr/>
+          <a:p/>
+        </p:txBody>
       </p:sp>
       <p:pic>
         <p:nvPicPr>
@@ -3697,6 +4401,10 @@
             <a:prstDash val="solid"/>
           </a:ln>
         </p:spPr>
+        <p:txBody>
+          <a:bodyPr/>
+          <a:p/>
+        </p:txBody>
       </p:sp>
       <p:sp>
         <p:nvSpPr>
@@ -3722,6 +4430,10 @@
             <a:prstDash val="solid"/>
           </a:ln>
         </p:spPr>
+        <p:txBody>
+          <a:bodyPr/>
+          <a:p/>
+        </p:txBody>
       </p:sp>
       <p:sp>
         <p:nvSpPr>
@@ -3825,6 +4537,10 @@
             <a:prstDash val="solid"/>
           </a:ln>
         </p:spPr>
+        <p:txBody>
+          <a:bodyPr/>
+          <a:p/>
+        </p:txBody>
       </p:sp>
       <p:sp>
         <p:nvSpPr>
@@ -3850,6 +4566,10 @@
             <a:prstDash val="solid"/>
           </a:ln>
         </p:spPr>
+        <p:txBody>
+          <a:bodyPr/>
+          <a:p/>
+        </p:txBody>
       </p:sp>
       <p:sp>
         <p:nvSpPr>
@@ -3953,6 +4673,10 @@
             <a:prstDash val="solid"/>
           </a:ln>
         </p:spPr>
+        <p:txBody>
+          <a:bodyPr/>
+          <a:p/>
+        </p:txBody>
       </p:sp>
       <p:sp>
         <p:nvSpPr>
@@ -3978,6 +4702,10 @@
             <a:prstDash val="solid"/>
           </a:ln>
         </p:spPr>
+        <p:txBody>
+          <a:bodyPr/>
+          <a:p/>
+        </p:txBody>
       </p:sp>
       <p:sp>
         <p:nvSpPr>
@@ -4090,7 +4818,7 @@
                 <a:ea typeface="Calibri" pitchFamily="34" charset="-122"/>
                 <a:cs typeface="Calibri" pitchFamily="34" charset="-120"/>
               </a:rPr>
-              <a:t>Hibrusi · Automatización · Proyecto Nebrija</a:t>
+              <a:t>Javier, David y Bruno · Automatización · Proyecto Nebrija</a:t>
             </a:r>
             <a:endParaRPr lang="en-US" sz="900" dirty="0"/>
           </a:p>
@@ -4269,6 +4997,10 @@
             <a:prstDash val="solid"/>
           </a:ln>
         </p:spPr>
+        <p:txBody>
+          <a:bodyPr/>
+          <a:p/>
+        </p:txBody>
       </p:sp>
       <p:sp>
         <p:nvSpPr>
@@ -4411,6 +5143,10 @@
             <a:prstDash val="solid"/>
           </a:ln>
         </p:spPr>
+        <p:txBody>
+          <a:bodyPr/>
+          <a:p/>
+        </p:txBody>
       </p:sp>
       <p:sp>
         <p:nvSpPr>
@@ -4553,6 +5289,10 @@
             <a:prstDash val="solid"/>
           </a:ln>
         </p:spPr>
+        <p:txBody>
+          <a:bodyPr/>
+          <a:p/>
+        </p:txBody>
       </p:sp>
       <p:sp>
         <p:nvSpPr>
@@ -4695,6 +5435,10 @@
             <a:prstDash val="solid"/>
           </a:ln>
         </p:spPr>
+        <p:txBody>
+          <a:bodyPr/>
+          <a:p/>
+        </p:txBody>
       </p:sp>
       <p:sp>
         <p:nvSpPr>
@@ -4837,6 +5581,10 @@
             <a:prstDash val="solid"/>
           </a:ln>
         </p:spPr>
+        <p:txBody>
+          <a:bodyPr/>
+          <a:p/>
+        </p:txBody>
       </p:sp>
       <p:sp>
         <p:nvSpPr>
@@ -4988,7 +5736,7 @@
                 <a:ea typeface="Calibri" pitchFamily="34" charset="-122"/>
                 <a:cs typeface="Calibri" pitchFamily="34" charset="-120"/>
               </a:rPr>
-              <a:t>Hibrusi · Automatización · Proyecto Nebrija</a:t>
+              <a:t>Javier, David y Bruno · Automatización · Proyecto Nebrija</a:t>
             </a:r>
             <a:endParaRPr lang="en-US" sz="900" dirty="0"/>
           </a:p>
@@ -5167,6 +5915,10 @@
             <a:prstDash val="solid"/>
           </a:ln>
         </p:spPr>
+        <p:txBody>
+          <a:bodyPr/>
+          <a:p/>
+        </p:txBody>
       </p:sp>
       <p:sp>
         <p:nvSpPr>
@@ -5192,6 +5944,10 @@
             <a:prstDash val="solid"/>
           </a:ln>
         </p:spPr>
+        <p:txBody>
+          <a:bodyPr/>
+          <a:p/>
+        </p:txBody>
       </p:sp>
       <p:sp>
         <p:nvSpPr>
@@ -5256,6 +6012,10 @@
             <a:prstDash val="solid"/>
           </a:ln>
         </p:spPr>
+        <p:txBody>
+          <a:bodyPr/>
+          <a:p/>
+        </p:txBody>
       </p:sp>
       <p:sp>
         <p:nvSpPr>
@@ -5281,6 +6041,10 @@
             <a:prstDash val="solid"/>
           </a:ln>
         </p:spPr>
+        <p:txBody>
+          <a:bodyPr/>
+          <a:p/>
+        </p:txBody>
       </p:sp>
       <p:sp>
         <p:nvSpPr>
@@ -5345,6 +6109,10 @@
             <a:prstDash val="solid"/>
           </a:ln>
         </p:spPr>
+        <p:txBody>
+          <a:bodyPr/>
+          <a:p/>
+        </p:txBody>
       </p:sp>
       <p:sp>
         <p:nvSpPr>
@@ -5370,6 +6138,10 @@
             <a:prstDash val="solid"/>
           </a:ln>
         </p:spPr>
+        <p:txBody>
+          <a:bodyPr/>
+          <a:p/>
+        </p:txBody>
       </p:sp>
       <p:sp>
         <p:nvSpPr>
@@ -5436,6 +6208,10 @@
             <a:prstDash val="solid"/>
           </a:ln>
         </p:spPr>
+        <p:txBody>
+          <a:bodyPr/>
+          <a:p/>
+        </p:txBody>
       </p:sp>
       <p:sp>
         <p:nvSpPr>
@@ -5541,6 +6317,10 @@
             <a:prstDash val="solid"/>
           </a:ln>
         </p:spPr>
+        <p:txBody>
+          <a:bodyPr/>
+          <a:p/>
+        </p:txBody>
       </p:sp>
       <p:sp>
         <p:nvSpPr>
@@ -5646,6 +6426,10 @@
             <a:prstDash val="solid"/>
           </a:ln>
         </p:spPr>
+        <p:txBody>
+          <a:bodyPr/>
+          <a:p/>
+        </p:txBody>
       </p:sp>
       <p:sp>
         <p:nvSpPr>
@@ -5751,6 +6535,10 @@
             <a:prstDash val="solid"/>
           </a:ln>
         </p:spPr>
+        <p:txBody>
+          <a:bodyPr/>
+          <a:p/>
+        </p:txBody>
       </p:sp>
       <p:sp>
         <p:nvSpPr>
@@ -5856,6 +6644,10 @@
             <a:prstDash val="solid"/>
           </a:ln>
         </p:spPr>
+        <p:txBody>
+          <a:bodyPr/>
+          <a:p/>
+        </p:txBody>
       </p:sp>
       <p:sp>
         <p:nvSpPr>
@@ -5961,6 +6753,10 @@
             <a:prstDash val="solid"/>
           </a:ln>
         </p:spPr>
+        <p:txBody>
+          <a:bodyPr/>
+          <a:p/>
+        </p:txBody>
       </p:sp>
       <p:sp>
         <p:nvSpPr>
@@ -6066,6 +6862,10 @@
             <a:prstDash val="solid"/>
           </a:ln>
         </p:spPr>
+        <p:txBody>
+          <a:bodyPr/>
+          <a:p/>
+        </p:txBody>
       </p:sp>
       <p:sp>
         <p:nvSpPr>
@@ -6171,6 +6971,10 @@
             <a:prstDash val="solid"/>
           </a:ln>
         </p:spPr>
+        <p:txBody>
+          <a:bodyPr/>
+          <a:p/>
+        </p:txBody>
       </p:sp>
       <p:sp>
         <p:nvSpPr>
@@ -6276,6 +7080,10 @@
             <a:prstDash val="solid"/>
           </a:ln>
         </p:spPr>
+        <p:txBody>
+          <a:bodyPr/>
+          <a:p/>
+        </p:txBody>
       </p:sp>
       <p:sp>
         <p:nvSpPr>
@@ -6378,6 +7186,10 @@
             <a:tailEnd type="triangle"/>
           </a:ln>
         </p:spPr>
+        <p:txBody>
+          <a:bodyPr/>
+          <a:p/>
+        </p:txBody>
       </p:sp>
       <p:sp>
         <p:nvSpPr>
@@ -6402,6 +7214,10 @@
             <a:tailEnd type="triangle"/>
           </a:ln>
         </p:spPr>
+        <p:txBody>
+          <a:bodyPr/>
+          <a:p/>
+        </p:txBody>
       </p:sp>
       <p:sp>
         <p:nvSpPr>
@@ -6426,6 +7242,10 @@
             <a:tailEnd type="triangle"/>
           </a:ln>
         </p:spPr>
+        <p:txBody>
+          <a:bodyPr/>
+          <a:p/>
+        </p:txBody>
       </p:sp>
       <p:sp>
         <p:nvSpPr>
@@ -6450,6 +7270,10 @@
             <a:tailEnd type="triangle"/>
           </a:ln>
         </p:spPr>
+        <p:txBody>
+          <a:bodyPr/>
+          <a:p/>
+        </p:txBody>
       </p:sp>
       <p:sp>
         <p:nvSpPr>
@@ -6474,6 +7298,10 @@
             <a:tailEnd type="triangle"/>
           </a:ln>
         </p:spPr>
+        <p:txBody>
+          <a:bodyPr/>
+          <a:p/>
+        </p:txBody>
       </p:sp>
       <p:sp>
         <p:nvSpPr>
@@ -6498,6 +7326,10 @@
             <a:tailEnd type="triangle"/>
           </a:ln>
         </p:spPr>
+        <p:txBody>
+          <a:bodyPr/>
+          <a:p/>
+        </p:txBody>
       </p:sp>
       <p:sp>
         <p:nvSpPr>
@@ -6522,6 +7354,10 @@
             <a:tailEnd type="triangle"/>
           </a:ln>
         </p:spPr>
+        <p:txBody>
+          <a:bodyPr/>
+          <a:p/>
+        </p:txBody>
       </p:sp>
       <p:sp>
         <p:nvSpPr>
@@ -6546,6 +7382,10 @@
             <a:tailEnd type="triangle"/>
           </a:ln>
         </p:spPr>
+        <p:txBody>
+          <a:bodyPr/>
+          <a:p/>
+        </p:txBody>
       </p:sp>
       <p:sp>
         <p:nvSpPr>
@@ -6580,7 +7420,7 @@
                 <a:ea typeface="Calibri" pitchFamily="34" charset="-122"/>
                 <a:cs typeface="Calibri" pitchFamily="34" charset="-120"/>
               </a:rPr>
-              <a:t>Hibrusi · Automatización · Proyecto Nebrija</a:t>
+              <a:t>Javier, David y Bruno · Automatización · Proyecto Nebrija</a:t>
             </a:r>
             <a:endParaRPr lang="en-US" sz="900" dirty="0"/>
           </a:p>
@@ -6761,6 +7601,10 @@
             <a:prstDash val="solid"/>
           </a:ln>
         </p:spPr>
+        <p:txBody>
+          <a:bodyPr/>
+          <a:p/>
+        </p:txBody>
       </p:sp>
       <p:sp>
         <p:nvSpPr>
@@ -6905,6 +7749,10 @@
             <a:prstDash val="solid"/>
           </a:ln>
         </p:spPr>
+        <p:txBody>
+          <a:bodyPr/>
+          <a:p/>
+        </p:txBody>
       </p:sp>
       <p:sp>
         <p:nvSpPr>
@@ -7049,6 +7897,10 @@
             <a:prstDash val="solid"/>
           </a:ln>
         </p:spPr>
+        <p:txBody>
+          <a:bodyPr/>
+          <a:p/>
+        </p:txBody>
       </p:sp>
       <p:sp>
         <p:nvSpPr>
@@ -7190,6 +8042,10 @@
             <a:tailEnd type="triangle"/>
           </a:ln>
         </p:spPr>
+        <p:txBody>
+          <a:bodyPr/>
+          <a:p/>
+        </p:txBody>
       </p:sp>
       <p:sp>
         <p:nvSpPr>
@@ -7214,6 +8070,10 @@
             <a:tailEnd type="triangle"/>
           </a:ln>
         </p:spPr>
+        <p:txBody>
+          <a:bodyPr/>
+          <a:p/>
+        </p:txBody>
       </p:sp>
       <p:sp>
         <p:nvSpPr>
@@ -7241,6 +8101,10 @@
             <a:prstDash val="solid"/>
           </a:ln>
         </p:spPr>
+        <p:txBody>
+          <a:bodyPr/>
+          <a:p/>
+        </p:txBody>
       </p:sp>
       <p:sp>
         <p:nvSpPr>
@@ -7382,6 +8246,10 @@
             <a:tailEnd type="triangle"/>
           </a:ln>
         </p:spPr>
+        <p:txBody>
+          <a:bodyPr/>
+          <a:p/>
+        </p:txBody>
       </p:sp>
       <p:sp>
         <p:nvSpPr>
@@ -7409,6 +8277,10 @@
             <a:prstDash val="solid"/>
           </a:ln>
         </p:spPr>
+        <p:txBody>
+          <a:bodyPr/>
+          <a:p/>
+        </p:txBody>
       </p:sp>
       <p:sp>
         <p:nvSpPr>
@@ -7553,6 +8425,10 @@
             <a:prstDash val="solid"/>
           </a:ln>
         </p:spPr>
+        <p:txBody>
+          <a:bodyPr/>
+          <a:p/>
+        </p:txBody>
       </p:sp>
       <p:sp>
         <p:nvSpPr>
@@ -7697,6 +8573,10 @@
             <a:prstDash val="solid"/>
           </a:ln>
         </p:spPr>
+        <p:txBody>
+          <a:bodyPr/>
+          <a:p/>
+        </p:txBody>
       </p:sp>
       <p:sp>
         <p:nvSpPr>
@@ -7838,6 +8718,10 @@
             <a:tailEnd type="triangle"/>
           </a:ln>
         </p:spPr>
+        <p:txBody>
+          <a:bodyPr/>
+          <a:p/>
+        </p:txBody>
       </p:sp>
       <p:sp>
         <p:nvSpPr>
@@ -7862,6 +8746,10 @@
             <a:tailEnd type="triangle"/>
           </a:ln>
         </p:spPr>
+        <p:txBody>
+          <a:bodyPr/>
+          <a:p/>
+        </p:txBody>
       </p:sp>
       <p:sp>
         <p:nvSpPr>
@@ -7886,6 +8774,10 @@
             <a:tailEnd type="triangle"/>
           </a:ln>
         </p:spPr>
+        <p:txBody>
+          <a:bodyPr/>
+          <a:p/>
+        </p:txBody>
       </p:sp>
       <p:sp>
         <p:nvSpPr>
@@ -7913,6 +8805,10 @@
             <a:prstDash val="solid"/>
           </a:ln>
         </p:spPr>
+        <p:txBody>
+          <a:bodyPr/>
+          <a:p/>
+        </p:txBody>
       </p:sp>
       <p:sp>
         <p:nvSpPr>
@@ -8035,6 +8931,10 @@
             <a:prstDash val="solid"/>
           </a:ln>
         </p:spPr>
+        <p:txBody>
+          <a:bodyPr/>
+          <a:p/>
+        </p:txBody>
       </p:sp>
       <p:sp>
         <p:nvSpPr>
@@ -8164,7 +9064,7 @@
                 <a:ea typeface="Calibri" pitchFamily="34" charset="-122"/>
                 <a:cs typeface="Calibri" pitchFamily="34" charset="-120"/>
               </a:rPr>
-              <a:t>Hibrusi · Automatización · Proyecto Nebrija</a:t>
+              <a:t>Javier, David y Bruno · Automatización · Proyecto Nebrija</a:t>
             </a:r>
             <a:endParaRPr lang="en-US" sz="900" dirty="0"/>
           </a:p>
@@ -8343,6 +9243,10 @@
             <a:prstDash val="solid"/>
           </a:ln>
         </p:spPr>
+        <p:txBody>
+          <a:bodyPr/>
+          <a:p/>
+        </p:txBody>
       </p:sp>
       <p:sp>
         <p:nvSpPr>
@@ -8368,6 +9272,10 @@
             <a:prstDash val="solid"/>
           </a:ln>
         </p:spPr>
+        <p:txBody>
+          <a:bodyPr/>
+          <a:p/>
+        </p:txBody>
       </p:sp>
       <p:pic>
         <p:nvPicPr>
@@ -8534,6 +9442,10 @@
             <a:prstDash val="solid"/>
           </a:ln>
         </p:spPr>
+        <p:txBody>
+          <a:bodyPr/>
+          <a:p/>
+        </p:txBody>
       </p:sp>
       <p:sp>
         <p:nvSpPr>
@@ -8559,6 +9471,10 @@
             <a:prstDash val="solid"/>
           </a:ln>
         </p:spPr>
+        <p:txBody>
+          <a:bodyPr/>
+          <a:p/>
+        </p:txBody>
       </p:sp>
       <p:pic>
         <p:nvPicPr>
@@ -8725,6 +9641,10 @@
             <a:prstDash val="solid"/>
           </a:ln>
         </p:spPr>
+        <p:txBody>
+          <a:bodyPr/>
+          <a:p/>
+        </p:txBody>
       </p:sp>
       <p:sp>
         <p:nvSpPr>
@@ -8750,6 +9670,10 @@
             <a:prstDash val="solid"/>
           </a:ln>
         </p:spPr>
+        <p:txBody>
+          <a:bodyPr/>
+          <a:p/>
+        </p:txBody>
       </p:sp>
       <p:pic>
         <p:nvPicPr>
@@ -8916,6 +9840,10 @@
             <a:prstDash val="solid"/>
           </a:ln>
         </p:spPr>
+        <p:txBody>
+          <a:bodyPr/>
+          <a:p/>
+        </p:txBody>
       </p:sp>
       <p:sp>
         <p:nvSpPr>
@@ -8941,6 +9869,10 @@
             <a:prstDash val="solid"/>
           </a:ln>
         </p:spPr>
+        <p:txBody>
+          <a:bodyPr/>
+          <a:p/>
+        </p:txBody>
       </p:sp>
       <p:pic>
         <p:nvPicPr>
@@ -9107,6 +10039,10 @@
             <a:prstDash val="solid"/>
           </a:ln>
         </p:spPr>
+        <p:txBody>
+          <a:bodyPr/>
+          <a:p/>
+        </p:txBody>
       </p:sp>
       <p:sp>
         <p:nvSpPr>
@@ -9132,6 +10068,10 @@
             <a:prstDash val="solid"/>
           </a:ln>
         </p:spPr>
+        <p:txBody>
+          <a:bodyPr/>
+          <a:p/>
+        </p:txBody>
       </p:sp>
       <p:pic>
         <p:nvPicPr>
@@ -9298,6 +10238,10 @@
             <a:prstDash val="solid"/>
           </a:ln>
         </p:spPr>
+        <p:txBody>
+          <a:bodyPr/>
+          <a:p/>
+        </p:txBody>
       </p:sp>
       <p:sp>
         <p:nvSpPr>
@@ -9323,6 +10267,10 @@
             <a:prstDash val="solid"/>
           </a:ln>
         </p:spPr>
+        <p:txBody>
+          <a:bodyPr/>
+          <a:p/>
+        </p:txBody>
       </p:sp>
       <p:pic>
         <p:nvPicPr>
@@ -9498,7 +10446,7 @@
                 <a:ea typeface="Calibri" pitchFamily="34" charset="-122"/>
                 <a:cs typeface="Calibri" pitchFamily="34" charset="-120"/>
               </a:rPr>
-              <a:t>Hibrusi · Automatización · Proyecto Nebrija</a:t>
+              <a:t>Javier, David y Bruno · Automatización · Proyecto Nebrija</a:t>
             </a:r>
             <a:endParaRPr lang="en-US" sz="900" dirty="0"/>
           </a:p>
@@ -9677,6 +10625,10 @@
             <a:prstDash val="solid"/>
           </a:ln>
         </p:spPr>
+        <p:txBody>
+          <a:bodyPr/>
+          <a:p/>
+        </p:txBody>
       </p:sp>
       <p:sp>
         <p:nvSpPr>
@@ -10673,7 +11625,7 @@
                 <a:ea typeface="Calibri" pitchFamily="34" charset="-122"/>
                 <a:cs typeface="Calibri" pitchFamily="34" charset="-120"/>
               </a:rPr>
-              <a:t>Hibrusi · Automatización · Proyecto Nebrija</a:t>
+              <a:t>Javier, David y Bruno · Automatización · Proyecto Nebrija</a:t>
             </a:r>
             <a:endParaRPr lang="en-US" sz="900" dirty="0"/>
           </a:p>
@@ -10852,6 +11804,10 @@
             <a:prstDash val="solid"/>
           </a:ln>
         </p:spPr>
+        <p:txBody>
+          <a:bodyPr/>
+          <a:p/>
+        </p:txBody>
       </p:sp>
       <p:sp>
         <p:nvSpPr>
@@ -10877,6 +11833,10 @@
             <a:prstDash val="solid"/>
           </a:ln>
         </p:spPr>
+        <p:txBody>
+          <a:bodyPr/>
+          <a:p/>
+        </p:txBody>
       </p:sp>
       <p:sp>
         <p:nvSpPr>
@@ -10902,6 +11862,10 @@
             <a:prstDash val="solid"/>
           </a:ln>
         </p:spPr>
+        <p:txBody>
+          <a:bodyPr/>
+          <a:p/>
+        </p:txBody>
       </p:sp>
       <p:sp>
         <p:nvSpPr>
@@ -10927,6 +11891,10 @@
             <a:prstDash val="solid"/>
           </a:ln>
         </p:spPr>
+        <p:txBody>
+          <a:bodyPr/>
+          <a:p/>
+        </p:txBody>
       </p:sp>
       <p:sp>
         <p:nvSpPr>
@@ -10952,6 +11920,10 @@
             <a:prstDash val="solid"/>
           </a:ln>
         </p:spPr>
+        <p:txBody>
+          <a:bodyPr/>
+          <a:p/>
+        </p:txBody>
       </p:sp>
       <p:sp>
         <p:nvSpPr>
@@ -11096,6 +12068,10 @@
             <a:prstDash val="solid"/>
           </a:ln>
         </p:spPr>
+        <p:txBody>
+          <a:bodyPr/>
+          <a:p/>
+        </p:txBody>
       </p:sp>
       <p:sp>
         <p:nvSpPr>
@@ -11121,6 +12097,10 @@
             <a:prstDash val="solid"/>
           </a:ln>
         </p:spPr>
+        <p:txBody>
+          <a:bodyPr/>
+          <a:p/>
+        </p:txBody>
       </p:sp>
       <p:sp>
         <p:nvSpPr>
@@ -11187,6 +12167,10 @@
             <a:prstDash val="solid"/>
           </a:ln>
         </p:spPr>
+        <p:txBody>
+          <a:bodyPr/>
+          <a:p/>
+        </p:txBody>
       </p:sp>
       <p:sp>
         <p:nvSpPr>
@@ -11212,6 +12196,10 @@
             <a:prstDash val="solid"/>
           </a:ln>
         </p:spPr>
+        <p:txBody>
+          <a:bodyPr/>
+          <a:p/>
+        </p:txBody>
       </p:sp>
       <p:sp>
         <p:nvSpPr>
@@ -11278,6 +12266,10 @@
             <a:prstDash val="solid"/>
           </a:ln>
         </p:spPr>
+        <p:txBody>
+          <a:bodyPr/>
+          <a:p/>
+        </p:txBody>
       </p:sp>
       <p:sp>
         <p:nvSpPr>
@@ -11303,6 +12295,10 @@
             <a:prstDash val="solid"/>
           </a:ln>
         </p:spPr>
+        <p:txBody>
+          <a:bodyPr/>
+          <a:p/>
+        </p:txBody>
       </p:sp>
       <p:sp>
         <p:nvSpPr>
@@ -11369,6 +12365,10 @@
             <a:prstDash val="solid"/>
           </a:ln>
         </p:spPr>
+        <p:txBody>
+          <a:bodyPr/>
+          <a:p/>
+        </p:txBody>
       </p:sp>
       <p:sp>
         <p:nvSpPr>
@@ -11394,6 +12394,10 @@
             <a:prstDash val="solid"/>
           </a:ln>
         </p:spPr>
+        <p:txBody>
+          <a:bodyPr/>
+          <a:p/>
+        </p:txBody>
       </p:sp>
       <p:sp>
         <p:nvSpPr>
@@ -11460,6 +12464,10 @@
             <a:prstDash val="solid"/>
           </a:ln>
         </p:spPr>
+        <p:txBody>
+          <a:bodyPr/>
+          <a:p/>
+        </p:txBody>
       </p:sp>
       <p:sp>
         <p:nvSpPr>
@@ -11485,6 +12493,10 @@
             <a:prstDash val="solid"/>
           </a:ln>
         </p:spPr>
+        <p:txBody>
+          <a:bodyPr/>
+          <a:p/>
+        </p:txBody>
       </p:sp>
       <p:sp>
         <p:nvSpPr>
@@ -11551,6 +12563,10 @@
             <a:prstDash val="solid"/>
           </a:ln>
         </p:spPr>
+        <p:txBody>
+          <a:bodyPr/>
+          <a:p/>
+        </p:txBody>
       </p:sp>
       <p:sp>
         <p:nvSpPr>
@@ -11576,6 +12592,10 @@
             <a:prstDash val="solid"/>
           </a:ln>
         </p:spPr>
+        <p:txBody>
+          <a:bodyPr/>
+          <a:p/>
+        </p:txBody>
       </p:sp>
       <p:sp>
         <p:nvSpPr>
@@ -11642,6 +12662,10 @@
             <a:prstDash val="solid"/>
           </a:ln>
         </p:spPr>
+        <p:txBody>
+          <a:bodyPr/>
+          <a:p/>
+        </p:txBody>
       </p:sp>
       <p:sp>
         <p:nvSpPr>
@@ -11860,7 +12884,7 @@
                 <a:ea typeface="Calibri" pitchFamily="34" charset="-122"/>
                 <a:cs typeface="Calibri" pitchFamily="34" charset="-120"/>
               </a:rPr>
-              <a:t>Hibrusi · Automatización · Proyecto Nebrija</a:t>
+              <a:t>Javier, David y Bruno · Automatización · Proyecto Nebrija</a:t>
             </a:r>
             <a:endParaRPr lang="en-US" sz="900" dirty="0"/>
           </a:p>
@@ -11914,13 +12938,14 @@
 </file>
 
 <file path=ppt/slides/slide9.xml><?xml version="1.0" encoding="utf-8"?>
-<p:sld xmlns:a="http://schemas.openxmlformats.org/drawingml/2006/main" xmlns:r="http://schemas.openxmlformats.org/officeDocument/2006/relationships" xmlns:p="http://schemas.openxmlformats.org/presentationml/2006/main">
-  <p:cSld name="Slide 9">
+<p:sld xmlns:a="http://schemas.openxmlformats.org/drawingml/2006/main" xmlns:p="http://schemas.openxmlformats.org/presentationml/2006/main" xmlns:r="http://schemas.openxmlformats.org/officeDocument/2006/relationships">
+  <p:cSld>
     <p:bg>
       <p:bgPr>
         <a:solidFill>
           <a:srgbClr val="FFFFFF"/>
         </a:solidFill>
+        <a:effectLst/>
       </p:bgPr>
     </p:bg>
     <p:spTree>
@@ -11929,18 +12954,11 @@
         <p:cNvGrpSpPr/>
         <p:nvPr/>
       </p:nvGrpSpPr>
-      <p:grpSpPr>
-        <a:xfrm>
-          <a:off x="0" y="0"/>
-          <a:ext cx="0" cy="0"/>
-          <a:chOff x="0" y="0"/>
-          <a:chExt cx="0" cy="0"/>
-        </a:xfrm>
-      </p:grpSpPr>
-      <p:sp>
-        <p:nvSpPr>
-          <p:cNvPr id="2" name="Text 0"/>
-          <p:cNvSpPr/>
+      <p:grpSpPr/>
+      <p:sp>
+        <p:nvSpPr>
+          <p:cNvPr id="2" name="TextBox 1"/>
+          <p:cNvSpPr txBox="1"/>
           <p:nvPr/>
         </p:nvSpPr>
         <p:spPr>
@@ -11952,524 +12970,846 @@
             <a:avLst/>
           </a:prstGeom>
           <a:noFill/>
-          <a:ln/>
-        </p:spPr>
-        <p:txBody>
-          <a:bodyPr wrap="square" lIns="0" tIns="0" rIns="0" bIns="0" rtlCol="0" anchor="ctr"/>
-          <a:lstStyle/>
-          <a:p>
-            <a:pPr indent="0" marL="0">
-              <a:buNone/>
-            </a:pPr>
-            <a:r>
-              <a:rPr lang="en-US" sz="3000" b="1" dirty="0">
+        </p:spPr>
+        <p:txBody>
+          <a:bodyPr wrap="square" anchor="t" lIns="0" rIns="0" tIns="0" bIns="0">
+            <a:spAutoFit/>
+          </a:bodyPr>
+          <a:lstStyle/>
+          <a:p>
+            <a:r>
+              <a:rPr sz="2800" b="1" u="none">
                 <a:solidFill>
                   <a:srgbClr val="1A2C52"/>
                 </a:solidFill>
-                <a:latin typeface="Calibri" pitchFamily="34" charset="0"/>
-                <a:ea typeface="Calibri" pitchFamily="34" charset="-122"/>
-                <a:cs typeface="Calibri" pitchFamily="34" charset="-120"/>
-              </a:rPr>
-              <a:t>Manual vs. automatizado</a:t>
-            </a:r>
-            <a:endParaRPr lang="en-US" sz="3000" dirty="0"/>
-          </a:p>
-        </p:txBody>
-      </p:sp>
-      <p:sp>
-        <p:nvSpPr>
-          <p:cNvPr id="3" name="Text 1"/>
-          <p:cNvSpPr/>
-          <p:nvPr/>
-        </p:nvSpPr>
-        <p:spPr>
-          <a:xfrm>
-            <a:off x="457200" y="960120"/>
+                <a:latin typeface="Calibri"/>
+              </a:rPr>
+              <a:t>Cómo usar la app — guía paso a paso</a:t>
+            </a:r>
+          </a:p>
+        </p:txBody>
+      </p:sp>
+      <p:sp>
+        <p:nvSpPr>
+          <p:cNvPr id="3" name="TextBox 2"/>
+          <p:cNvSpPr txBox="1"/>
+          <p:nvPr/>
+        </p:nvSpPr>
+        <p:spPr>
+          <a:xfrm>
+            <a:off x="457200" y="932688"/>
             <a:ext cx="8229600" cy="320040"/>
           </a:xfrm>
           <a:prstGeom prst="rect">
             <a:avLst/>
           </a:prstGeom>
           <a:noFill/>
-          <a:ln/>
-        </p:spPr>
-        <p:txBody>
-          <a:bodyPr wrap="square" lIns="0" tIns="0" rIns="0" bIns="0" rtlCol="0" anchor="ctr"/>
-          <a:lstStyle/>
-          <a:p>
-            <a:pPr indent="0" marL="0">
-              <a:buNone/>
-            </a:pPr>
-            <a:r>
-              <a:rPr lang="en-US" sz="1400" i="1" dirty="0">
+        </p:spPr>
+        <p:txBody>
+          <a:bodyPr wrap="square" anchor="t" lIns="0" rIns="0" tIns="0" bIns="0">
+            <a:spAutoFit/>
+          </a:bodyPr>
+          <a:lstStyle/>
+          <a:p>
+            <a:r>
+              <a:rPr sz="1400" b="0" u="none">
                 <a:solidFill>
                   <a:srgbClr val="475569"/>
                 </a:solidFill>
-                <a:latin typeface="Calibri" pitchFamily="34" charset="0"/>
-                <a:ea typeface="Calibri" pitchFamily="34" charset="-122"/>
-                <a:cs typeface="Calibri" pitchFamily="34" charset="-120"/>
-              </a:rPr>
-              <a:t>Comparativa de tiempo de ejecución y otros indicadores</a:t>
-            </a:r>
-            <a:endParaRPr lang="en-US" sz="1400" dirty="0"/>
-          </a:p>
-        </p:txBody>
-      </p:sp>
-      <p:graphicFrame>
-        <p:nvGraphicFramePr>
-          <p:cNvPr id="4" name="Chart 0" descr=""/>
-          <p:cNvGraphicFramePr/>
-          <p:nvPr/>
-        </p:nvGraphicFramePr>
-        <p:xfrm>
-          <a:off x="457200" y="1417320"/>
-          <a:ext cx="5029200" cy="3200400"/>
-        </p:xfrm>
-        <a:graphic xmlns:a="http://schemas.openxmlformats.org/drawingml/2006/main">
-          <a:graphicData uri="http://schemas.openxmlformats.org/drawingml/2006/chart">
-            <c:chart xmlns:c="http://schemas.openxmlformats.org/drawingml/2006/chart" r:id="rId1"/>
-          </a:graphicData>
-        </a:graphic>
-      </p:graphicFrame>
-      <p:sp>
-        <p:nvSpPr>
-          <p:cNvPr id="5" name="Shape 2"/>
-          <p:cNvSpPr/>
-          <p:nvPr/>
-        </p:nvSpPr>
-        <p:spPr>
-          <a:xfrm>
-            <a:off x="5852160" y="1463040"/>
-            <a:ext cx="2834640" cy="914400"/>
-          </a:xfrm>
-          <a:prstGeom prst="rect">
-            <a:avLst/>
-          </a:prstGeom>
-          <a:solidFill>
-            <a:srgbClr val="EEF4FF"/>
-          </a:solidFill>
-          <a:ln w="12700">
-            <a:solidFill>
-              <a:srgbClr val="B8C8E8"/>
-            </a:solidFill>
-            <a:prstDash val="solid"/>
-          </a:ln>
-        </p:spPr>
-      </p:sp>
-      <p:sp>
-        <p:nvSpPr>
-          <p:cNvPr id="6" name="Shape 3"/>
-          <p:cNvSpPr/>
-          <p:nvPr/>
-        </p:nvSpPr>
-        <p:spPr>
-          <a:xfrm>
-            <a:off x="5852160" y="1463040"/>
-            <a:ext cx="73152" cy="914400"/>
-          </a:xfrm>
-          <a:prstGeom prst="rect">
+                <a:latin typeface="Calibri"/>
+              </a:rPr>
+              <a:t>Sigue estos pasos en orden · los enlaces en naranja son clicables</a:t>
+            </a:r>
+          </a:p>
+        </p:txBody>
+      </p:sp>
+      <p:sp>
+        <p:nvSpPr>
+          <p:cNvPr id="4" name="Rounded Rectangle 3"/>
+          <p:cNvSpPr/>
+          <p:nvPr/>
+        </p:nvSpPr>
+        <p:spPr>
+          <a:xfrm>
+            <a:off x="457200" y="1417320"/>
+            <a:ext cx="457200" cy="457200"/>
+          </a:xfrm>
+          <a:prstGeom prst="roundRect">
             <a:avLst/>
           </a:prstGeom>
           <a:solidFill>
             <a:srgbClr val="FF7A18"/>
           </a:solidFill>
-          <a:ln w="12700">
-            <a:solidFill>
-              <a:srgbClr val="FF7A18"/>
-            </a:solidFill>
-            <a:prstDash val="solid"/>
+          <a:ln>
+            <a:noFill/>
           </a:ln>
-        </p:spPr>
-      </p:sp>
-      <p:sp>
-        <p:nvSpPr>
-          <p:cNvPr id="7" name="Text 4"/>
-          <p:cNvSpPr/>
-          <p:nvPr/>
-        </p:nvSpPr>
-        <p:spPr>
-          <a:xfrm>
-            <a:off x="6035040" y="1508760"/>
-            <a:ext cx="1371600" cy="502920"/>
-          </a:xfrm>
-          <a:prstGeom prst="rect">
-            <a:avLst/>
-          </a:prstGeom>
-          <a:noFill/>
-          <a:ln/>
-        </p:spPr>
-        <p:txBody>
-          <a:bodyPr wrap="square" lIns="0" tIns="0" rIns="0" bIns="0" rtlCol="0" anchor="ctr"/>
-          <a:lstStyle/>
-          <a:p>
-            <a:pPr indent="0" marL="0">
-              <a:buNone/>
-            </a:pPr>
-            <a:r>
-              <a:rPr lang="en-US" sz="3000" b="1" dirty="0">
+          <a:effectLst/>
+        </p:spPr>
+        <p:style>
+          <a:lnRef idx="1">
+            <a:schemeClr val="accent1"/>
+          </a:lnRef>
+          <a:fillRef idx="3">
+            <a:schemeClr val="accent1"/>
+          </a:fillRef>
+          <a:effectRef idx="2">
+            <a:schemeClr val="accent1"/>
+          </a:effectRef>
+          <a:fontRef idx="minor">
+            <a:schemeClr val="lt1"/>
+          </a:fontRef>
+        </p:style>
+        <p:txBody>
+          <a:bodyPr rtlCol="0" anchor="ctr" wrap="square"/>
+          <a:lstStyle/>
+          <a:p>
+            <a:pPr algn="ctr"/>
+            <a:r>
+              <a:rPr sz="1600" b="1" u="none">
+                <a:solidFill>
+                  <a:srgbClr val="FFFFFF"/>
+                </a:solidFill>
+                <a:latin typeface="Calibri"/>
+              </a:rPr>
+              <a:t>1</a:t>
+            </a:r>
+          </a:p>
+        </p:txBody>
+      </p:sp>
+      <p:sp>
+        <p:nvSpPr>
+          <p:cNvPr id="5" name="TextBox 4"/>
+          <p:cNvSpPr txBox="1"/>
+          <p:nvPr/>
+        </p:nvSpPr>
+        <p:spPr>
+          <a:xfrm>
+            <a:off x="1097280" y="1417320"/>
+            <a:ext cx="2377440" cy="457200"/>
+          </a:xfrm>
+          <a:prstGeom prst="rect">
+            <a:avLst/>
+          </a:prstGeom>
+          <a:noFill/>
+        </p:spPr>
+        <p:txBody>
+          <a:bodyPr wrap="square" anchor="ctr" lIns="0" rIns="0" tIns="0" bIns="0">
+            <a:spAutoFit/>
+          </a:bodyPr>
+          <a:lstStyle/>
+          <a:p>
+            <a:r>
+              <a:rPr sz="1200" b="1" u="none">
                 <a:solidFill>
                   <a:srgbClr val="1A2C52"/>
                 </a:solidFill>
-                <a:latin typeface="Georgia" pitchFamily="34" charset="0"/>
-                <a:ea typeface="Georgia" pitchFamily="34" charset="-122"/>
-                <a:cs typeface="Georgia" pitchFamily="34" charset="-120"/>
-              </a:rPr>
-              <a:t>80×</a:t>
-            </a:r>
-            <a:endParaRPr lang="en-US" sz="3000" dirty="0"/>
-          </a:p>
-        </p:txBody>
-      </p:sp>
-      <p:sp>
-        <p:nvSpPr>
-          <p:cNvPr id="8" name="Text 5"/>
-          <p:cNvSpPr/>
-          <p:nvPr/>
-        </p:nvSpPr>
-        <p:spPr>
-          <a:xfrm>
-            <a:off x="7406640" y="1600200"/>
-            <a:ext cx="1188720" cy="685800"/>
-          </a:xfrm>
-          <a:prstGeom prst="rect">
-            <a:avLst/>
-          </a:prstGeom>
-          <a:noFill/>
-          <a:ln/>
-        </p:spPr>
-        <p:txBody>
-          <a:bodyPr wrap="square" lIns="0" tIns="0" rIns="0" bIns="0" rtlCol="0" anchor="ctr"/>
-          <a:lstStyle/>
-          <a:p>
-            <a:pPr indent="0" marL="0">
-              <a:buNone/>
-            </a:pPr>
-            <a:r>
-              <a:rPr lang="en-US" sz="1050" b="1" dirty="0">
-                <a:solidFill>
-                  <a:srgbClr val="1A2C52"/>
-                </a:solidFill>
-                <a:latin typeface="Calibri" pitchFamily="34" charset="0"/>
-                <a:ea typeface="Calibri" pitchFamily="34" charset="-122"/>
-                <a:cs typeface="Calibri" pitchFamily="34" charset="-120"/>
-              </a:rPr>
-              <a:t>más rápido</a:t>
-            </a:r>
-            <a:endParaRPr lang="en-US" sz="1050" dirty="0"/>
-          </a:p>
-          <a:p>
-            <a:pPr indent="0" marL="0">
-              <a:buNone/>
-            </a:pPr>
-            <a:r>
-              <a:rPr lang="en-US" sz="900" dirty="0">
-                <a:solidFill>
-                  <a:srgbClr val="475569"/>
-                </a:solidFill>
-                <a:latin typeface="Calibri" pitchFamily="34" charset="0"/>
-                <a:ea typeface="Calibri" pitchFamily="34" charset="-122"/>
-                <a:cs typeface="Calibri" pitchFamily="34" charset="-120"/>
-              </a:rPr>
-              <a:t>20 min → 15 seg</a:t>
-            </a:r>
-            <a:endParaRPr lang="en-US" sz="1050" dirty="0"/>
-          </a:p>
-        </p:txBody>
-      </p:sp>
-      <p:sp>
-        <p:nvSpPr>
-          <p:cNvPr id="9" name="Shape 6"/>
-          <p:cNvSpPr/>
-          <p:nvPr/>
-        </p:nvSpPr>
-        <p:spPr>
-          <a:xfrm>
-            <a:off x="5852160" y="2542032"/>
-            <a:ext cx="2834640" cy="914400"/>
-          </a:xfrm>
-          <a:prstGeom prst="rect">
-            <a:avLst/>
-          </a:prstGeom>
-          <a:solidFill>
-            <a:srgbClr val="EEF4FF"/>
-          </a:solidFill>
-          <a:ln w="12700">
-            <a:solidFill>
-              <a:srgbClr val="B8C8E8"/>
-            </a:solidFill>
-            <a:prstDash val="solid"/>
-          </a:ln>
-        </p:spPr>
-      </p:sp>
-      <p:sp>
-        <p:nvSpPr>
-          <p:cNvPr id="10" name="Shape 7"/>
-          <p:cNvSpPr/>
-          <p:nvPr/>
-        </p:nvSpPr>
-        <p:spPr>
-          <a:xfrm>
-            <a:off x="5852160" y="2542032"/>
-            <a:ext cx="73152" cy="914400"/>
-          </a:xfrm>
-          <a:prstGeom prst="rect">
+                <a:latin typeface="Calibri"/>
+              </a:rPr>
+              <a:t>Instala Python y lanza la app</a:t>
+            </a:r>
+          </a:p>
+        </p:txBody>
+      </p:sp>
+      <p:sp>
+        <p:nvSpPr>
+          <p:cNvPr id="6" name="TextBox 5"/>
+          <p:cNvSpPr txBox="1"/>
+          <p:nvPr/>
+        </p:nvSpPr>
+        <p:spPr>
+          <a:xfrm>
+            <a:off x="3566160" y="1417320"/>
+            <a:ext cx="5212080" cy="457200"/>
+          </a:xfrm>
+          <a:prstGeom prst="rect">
+            <a:avLst/>
+          </a:prstGeom>
+          <a:noFill/>
+        </p:spPr>
+        <p:txBody>
+          <a:bodyPr wrap="square" anchor="ctr" lIns="0" rIns="0" tIns="0" bIns="0">
+            <a:spAutoFit/>
+          </a:bodyPr>
+          <a:lstStyle/>
+          <a:p>
+            <a:r>
+              <a:rPr sz="1050" b="0" u="none">
+                <a:solidFill>
+                  <a:srgbClr val="0D1A36"/>
+                </a:solidFill>
+                <a:latin typeface="Calibri"/>
+              </a:rPr>
+              <a:t>Descarga Python en </a:t>
+            </a:r>
+            <a:r>
+              <a:rPr sz="1050" b="0" u="sng">
+                <a:solidFill>
+                  <a:srgbClr val="C04A00"/>
+                </a:solidFill>
+                <a:latin typeface="Calibri"/>
+                <a:hlinkClick r:id="rId2"/>
+              </a:rPr>
+              <a:t>python.org/downloads</a:t>
+            </a:r>
+            <a:r>
+              <a:rPr sz="1050" b="0" u="none">
+                <a:solidFill>
+                  <a:srgbClr val="0D1A36"/>
+                </a:solidFill>
+                <a:latin typeface="Calibri"/>
+              </a:rPr>
+              <a:t> · luego: pip install -r requirements.txt  y  python app.py</a:t>
+            </a:r>
+          </a:p>
+        </p:txBody>
+      </p:sp>
+      <p:sp>
+        <p:nvSpPr>
+          <p:cNvPr id="7" name="Rounded Rectangle 6"/>
+          <p:cNvSpPr/>
+          <p:nvPr/>
+        </p:nvSpPr>
+        <p:spPr>
+          <a:xfrm>
+            <a:off x="457200" y="1979676"/>
+            <a:ext cx="457200" cy="457200"/>
+          </a:xfrm>
+          <a:prstGeom prst="roundRect">
             <a:avLst/>
           </a:prstGeom>
           <a:solidFill>
             <a:srgbClr val="FF7A18"/>
           </a:solidFill>
-          <a:ln w="12700">
-            <a:solidFill>
-              <a:srgbClr val="FF7A18"/>
-            </a:solidFill>
-            <a:prstDash val="solid"/>
+          <a:ln>
+            <a:noFill/>
           </a:ln>
-        </p:spPr>
-      </p:sp>
-      <p:sp>
-        <p:nvSpPr>
-          <p:cNvPr id="11" name="Text 8"/>
-          <p:cNvSpPr/>
-          <p:nvPr/>
-        </p:nvSpPr>
-        <p:spPr>
-          <a:xfrm>
-            <a:off x="6035040" y="2587752"/>
-            <a:ext cx="1371600" cy="502920"/>
-          </a:xfrm>
-          <a:prstGeom prst="rect">
-            <a:avLst/>
-          </a:prstGeom>
-          <a:noFill/>
-          <a:ln/>
-        </p:spPr>
-        <p:txBody>
-          <a:bodyPr wrap="square" lIns="0" tIns="0" rIns="0" bIns="0" rtlCol="0" anchor="ctr"/>
-          <a:lstStyle/>
-          <a:p>
-            <a:pPr indent="0" marL="0">
-              <a:buNone/>
-            </a:pPr>
-            <a:r>
-              <a:rPr lang="en-US" sz="3000" b="1" dirty="0">
+          <a:effectLst/>
+        </p:spPr>
+        <p:style>
+          <a:lnRef idx="1">
+            <a:schemeClr val="accent1"/>
+          </a:lnRef>
+          <a:fillRef idx="3">
+            <a:schemeClr val="accent1"/>
+          </a:fillRef>
+          <a:effectRef idx="2">
+            <a:schemeClr val="accent1"/>
+          </a:effectRef>
+          <a:fontRef idx="minor">
+            <a:schemeClr val="lt1"/>
+          </a:fontRef>
+        </p:style>
+        <p:txBody>
+          <a:bodyPr rtlCol="0" anchor="ctr" wrap="square"/>
+          <a:lstStyle/>
+          <a:p>
+            <a:pPr algn="ctr"/>
+            <a:r>
+              <a:rPr sz="1600" b="1" u="none">
+                <a:solidFill>
+                  <a:srgbClr val="FFFFFF"/>
+                </a:solidFill>
+                <a:latin typeface="Calibri"/>
+              </a:rPr>
+              <a:t>2</a:t>
+            </a:r>
+          </a:p>
+        </p:txBody>
+      </p:sp>
+      <p:sp>
+        <p:nvSpPr>
+          <p:cNvPr id="8" name="TextBox 7"/>
+          <p:cNvSpPr txBox="1"/>
+          <p:nvPr/>
+        </p:nvSpPr>
+        <p:spPr>
+          <a:xfrm>
+            <a:off x="1097280" y="1979676"/>
+            <a:ext cx="2377440" cy="457200"/>
+          </a:xfrm>
+          <a:prstGeom prst="rect">
+            <a:avLst/>
+          </a:prstGeom>
+          <a:noFill/>
+        </p:spPr>
+        <p:txBody>
+          <a:bodyPr wrap="square" anchor="ctr" lIns="0" rIns="0" tIns="0" bIns="0">
+            <a:spAutoFit/>
+          </a:bodyPr>
+          <a:lstStyle/>
+          <a:p>
+            <a:r>
+              <a:rPr sz="1200" b="1" u="none">
                 <a:solidFill>
                   <a:srgbClr val="1A2C52"/>
                 </a:solidFill>
-                <a:latin typeface="Georgia" pitchFamily="34" charset="0"/>
-                <a:ea typeface="Georgia" pitchFamily="34" charset="-122"/>
-                <a:cs typeface="Georgia" pitchFamily="34" charset="-120"/>
-              </a:rPr>
-              <a:t>0%</a:t>
-            </a:r>
-            <a:endParaRPr lang="en-US" sz="3000" dirty="0"/>
-          </a:p>
-        </p:txBody>
-      </p:sp>
-      <p:sp>
-        <p:nvSpPr>
-          <p:cNvPr id="12" name="Text 9"/>
-          <p:cNvSpPr/>
-          <p:nvPr/>
-        </p:nvSpPr>
-        <p:spPr>
-          <a:xfrm>
-            <a:off x="7406640" y="2679192"/>
-            <a:ext cx="1188720" cy="685800"/>
-          </a:xfrm>
-          <a:prstGeom prst="rect">
-            <a:avLst/>
-          </a:prstGeom>
-          <a:noFill/>
-          <a:ln/>
-        </p:spPr>
-        <p:txBody>
-          <a:bodyPr wrap="square" lIns="0" tIns="0" rIns="0" bIns="0" rtlCol="0" anchor="ctr"/>
-          <a:lstStyle/>
-          <a:p>
-            <a:pPr indent="0" marL="0">
-              <a:buNone/>
-            </a:pPr>
-            <a:r>
-              <a:rPr lang="en-US" sz="1050" b="1" dirty="0">
-                <a:solidFill>
-                  <a:srgbClr val="1A2C52"/>
-                </a:solidFill>
-                <a:latin typeface="Calibri" pitchFamily="34" charset="0"/>
-                <a:ea typeface="Calibri" pitchFamily="34" charset="-122"/>
-                <a:cs typeface="Calibri" pitchFamily="34" charset="-120"/>
-              </a:rPr>
-              <a:t>tasa de error</a:t>
-            </a:r>
-            <a:endParaRPr lang="en-US" sz="1050" dirty="0"/>
-          </a:p>
-          <a:p>
-            <a:pPr indent="0" marL="0">
-              <a:buNone/>
-            </a:pPr>
-            <a:r>
-              <a:rPr lang="en-US" sz="900" dirty="0">
-                <a:solidFill>
-                  <a:srgbClr val="475569"/>
-                </a:solidFill>
-                <a:latin typeface="Calibri" pitchFamily="34" charset="0"/>
-                <a:ea typeface="Calibri" pitchFamily="34" charset="-122"/>
-                <a:cs typeface="Calibri" pitchFamily="34" charset="-120"/>
-              </a:rPr>
-              <a:t>vs. 5–10% manual</a:t>
-            </a:r>
-            <a:endParaRPr lang="en-US" sz="1050" dirty="0"/>
-          </a:p>
-        </p:txBody>
-      </p:sp>
-      <p:sp>
-        <p:nvSpPr>
-          <p:cNvPr id="13" name="Shape 10"/>
-          <p:cNvSpPr/>
-          <p:nvPr/>
-        </p:nvSpPr>
-        <p:spPr>
-          <a:xfrm>
-            <a:off x="5852160" y="3621024"/>
-            <a:ext cx="2834640" cy="914400"/>
-          </a:xfrm>
-          <a:prstGeom prst="rect">
-            <a:avLst/>
-          </a:prstGeom>
-          <a:solidFill>
-            <a:srgbClr val="EEF4FF"/>
-          </a:solidFill>
-          <a:ln w="12700">
-            <a:solidFill>
-              <a:srgbClr val="B8C8E8"/>
-            </a:solidFill>
-            <a:prstDash val="solid"/>
-          </a:ln>
-        </p:spPr>
-      </p:sp>
-      <p:sp>
-        <p:nvSpPr>
-          <p:cNvPr id="14" name="Shape 11"/>
-          <p:cNvSpPr/>
-          <p:nvPr/>
-        </p:nvSpPr>
-        <p:spPr>
-          <a:xfrm>
-            <a:off x="5852160" y="3621024"/>
-            <a:ext cx="73152" cy="914400"/>
-          </a:xfrm>
-          <a:prstGeom prst="rect">
+                <a:latin typeface="Calibri"/>
+              </a:rPr>
+              <a:t>Abre la app en el navegador</a:t>
+            </a:r>
+          </a:p>
+        </p:txBody>
+      </p:sp>
+      <p:sp>
+        <p:nvSpPr>
+          <p:cNvPr id="9" name="TextBox 8"/>
+          <p:cNvSpPr txBox="1"/>
+          <p:nvPr/>
+        </p:nvSpPr>
+        <p:spPr>
+          <a:xfrm>
+            <a:off x="3566160" y="1979676"/>
+            <a:ext cx="5212080" cy="457200"/>
+          </a:xfrm>
+          <a:prstGeom prst="rect">
+            <a:avLst/>
+          </a:prstGeom>
+          <a:noFill/>
+        </p:spPr>
+        <p:txBody>
+          <a:bodyPr wrap="square" anchor="ctr" lIns="0" rIns="0" tIns="0" bIns="0">
+            <a:spAutoFit/>
+          </a:bodyPr>
+          <a:lstStyle/>
+          <a:p>
+            <a:r>
+              <a:rPr sz="1050" b="0" u="none">
+                <a:solidFill>
+                  <a:srgbClr val="0D1A36"/>
+                </a:solidFill>
+                <a:latin typeface="Calibri"/>
+              </a:rPr>
+              <a:t>Entra en </a:t>
+            </a:r>
+            <a:r>
+              <a:rPr sz="1050" b="0" u="sng">
+                <a:solidFill>
+                  <a:srgbClr val="C04A00"/>
+                </a:solidFill>
+                <a:latin typeface="Calibri"/>
+                <a:hlinkClick r:id="rId3"/>
+              </a:rPr>
+              <a:t>http://127.0.0.1:8000</a:t>
+            </a:r>
+            <a:r>
+              <a:rPr sz="1050" b="0" u="none">
+                <a:solidFill>
+                  <a:srgbClr val="0D1A36"/>
+                </a:solidFill>
+                <a:latin typeface="Calibri"/>
+              </a:rPr>
+              <a:t>  (se abre el formulario web)</a:t>
+            </a:r>
+          </a:p>
+        </p:txBody>
+      </p:sp>
+      <p:sp>
+        <p:nvSpPr>
+          <p:cNvPr id="10" name="Rounded Rectangle 9"/>
+          <p:cNvSpPr/>
+          <p:nvPr/>
+        </p:nvSpPr>
+        <p:spPr>
+          <a:xfrm>
+            <a:off x="457200" y="2542032"/>
+            <a:ext cx="457200" cy="457200"/>
+          </a:xfrm>
+          <a:prstGeom prst="roundRect">
             <a:avLst/>
           </a:prstGeom>
           <a:solidFill>
             <a:srgbClr val="FF7A18"/>
           </a:solidFill>
-          <a:ln w="12700">
-            <a:solidFill>
-              <a:srgbClr val="FF7A18"/>
-            </a:solidFill>
-            <a:prstDash val="solid"/>
+          <a:ln>
+            <a:noFill/>
           </a:ln>
-        </p:spPr>
-      </p:sp>
-      <p:sp>
-        <p:nvSpPr>
-          <p:cNvPr id="15" name="Text 12"/>
-          <p:cNvSpPr/>
-          <p:nvPr/>
-        </p:nvSpPr>
-        <p:spPr>
-          <a:xfrm>
-            <a:off x="6035040" y="3666744"/>
-            <a:ext cx="1371600" cy="502920"/>
-          </a:xfrm>
-          <a:prstGeom prst="rect">
-            <a:avLst/>
-          </a:prstGeom>
-          <a:noFill/>
-          <a:ln/>
-        </p:spPr>
-        <p:txBody>
-          <a:bodyPr wrap="square" lIns="0" tIns="0" rIns="0" bIns="0" rtlCol="0" anchor="ctr"/>
-          <a:lstStyle/>
-          <a:p>
-            <a:pPr indent="0" marL="0">
-              <a:buNone/>
-            </a:pPr>
-            <a:r>
-              <a:rPr lang="en-US" sz="3000" b="1" dirty="0">
+          <a:effectLst/>
+        </p:spPr>
+        <p:style>
+          <a:lnRef idx="1">
+            <a:schemeClr val="accent1"/>
+          </a:lnRef>
+          <a:fillRef idx="3">
+            <a:schemeClr val="accent1"/>
+          </a:fillRef>
+          <a:effectRef idx="2">
+            <a:schemeClr val="accent1"/>
+          </a:effectRef>
+          <a:fontRef idx="minor">
+            <a:schemeClr val="lt1"/>
+          </a:fontRef>
+        </p:style>
+        <p:txBody>
+          <a:bodyPr rtlCol="0" anchor="ctr" wrap="square"/>
+          <a:lstStyle/>
+          <a:p>
+            <a:pPr algn="ctr"/>
+            <a:r>
+              <a:rPr sz="1600" b="1" u="none">
+                <a:solidFill>
+                  <a:srgbClr val="FFFFFF"/>
+                </a:solidFill>
+                <a:latin typeface="Calibri"/>
+              </a:rPr>
+              <a:t>3</a:t>
+            </a:r>
+          </a:p>
+        </p:txBody>
+      </p:sp>
+      <p:sp>
+        <p:nvSpPr>
+          <p:cNvPr id="11" name="TextBox 10"/>
+          <p:cNvSpPr txBox="1"/>
+          <p:nvPr/>
+        </p:nvSpPr>
+        <p:spPr>
+          <a:xfrm>
+            <a:off x="1097280" y="2542032"/>
+            <a:ext cx="2377440" cy="457200"/>
+          </a:xfrm>
+          <a:prstGeom prst="rect">
+            <a:avLst/>
+          </a:prstGeom>
+          <a:noFill/>
+        </p:spPr>
+        <p:txBody>
+          <a:bodyPr wrap="square" anchor="ctr" lIns="0" rIns="0" tIns="0" bIns="0">
+            <a:spAutoFit/>
+          </a:bodyPr>
+          <a:lstStyle/>
+          <a:p>
+            <a:r>
+              <a:rPr sz="1200" b="1" u="none">
                 <a:solidFill>
                   <a:srgbClr val="1A2C52"/>
                 </a:solidFill>
-                <a:latin typeface="Georgia" pitchFamily="34" charset="0"/>
-                <a:ea typeface="Georgia" pitchFamily="34" charset="-122"/>
-                <a:cs typeface="Georgia" pitchFamily="34" charset="-120"/>
-              </a:rPr>
-              <a:t>+3</a:t>
-            </a:r>
-            <a:endParaRPr lang="en-US" sz="3000" dirty="0"/>
-          </a:p>
-        </p:txBody>
-      </p:sp>
-      <p:sp>
-        <p:nvSpPr>
-          <p:cNvPr id="16" name="Text 13"/>
-          <p:cNvSpPr/>
-          <p:nvPr/>
-        </p:nvSpPr>
-        <p:spPr>
-          <a:xfrm>
-            <a:off x="7406640" y="3758184"/>
-            <a:ext cx="1188720" cy="685800"/>
-          </a:xfrm>
-          <a:prstGeom prst="rect">
-            <a:avLst/>
-          </a:prstGeom>
-          <a:noFill/>
-          <a:ln/>
-        </p:spPr>
-        <p:txBody>
-          <a:bodyPr wrap="square" lIns="0" tIns="0" rIns="0" bIns="0" rtlCol="0" anchor="ctr"/>
-          <a:lstStyle/>
-          <a:p>
-            <a:pPr indent="0" marL="0">
-              <a:buNone/>
-            </a:pPr>
-            <a:r>
-              <a:rPr lang="en-US" sz="1050" b="1" dirty="0">
+                <a:latin typeface="Calibri"/>
+              </a:rPr>
+              <a:t>Selecciona ciudades y días</a:t>
+            </a:r>
+          </a:p>
+        </p:txBody>
+      </p:sp>
+      <p:sp>
+        <p:nvSpPr>
+          <p:cNvPr id="12" name="TextBox 11"/>
+          <p:cNvSpPr txBox="1"/>
+          <p:nvPr/>
+        </p:nvSpPr>
+        <p:spPr>
+          <a:xfrm>
+            <a:off x="3566160" y="2542032"/>
+            <a:ext cx="5212080" cy="457200"/>
+          </a:xfrm>
+          <a:prstGeom prst="rect">
+            <a:avLst/>
+          </a:prstGeom>
+          <a:noFill/>
+        </p:spPr>
+        <p:txBody>
+          <a:bodyPr wrap="square" anchor="ctr" lIns="0" rIns="0" tIns="0" bIns="0">
+            <a:spAutoFit/>
+          </a:bodyPr>
+          <a:lstStyle/>
+          <a:p>
+            <a:r>
+              <a:rPr sz="1050" b="0" u="none">
+                <a:solidFill>
+                  <a:srgbClr val="0D1A36"/>
+                </a:solidFill>
+                <a:latin typeface="Calibri"/>
+              </a:rPr>
+              <a:t>Marca las ciudades a consultar y elige el horizonte de previsión (1–16 días).</a:t>
+            </a:r>
+          </a:p>
+        </p:txBody>
+      </p:sp>
+      <p:sp>
+        <p:nvSpPr>
+          <p:cNvPr id="13" name="Rounded Rectangle 12"/>
+          <p:cNvSpPr/>
+          <p:nvPr/>
+        </p:nvSpPr>
+        <p:spPr>
+          <a:xfrm>
+            <a:off x="457200" y="3104388"/>
+            <a:ext cx="457200" cy="457200"/>
+          </a:xfrm>
+          <a:prstGeom prst="roundRect">
+            <a:avLst/>
+          </a:prstGeom>
+          <a:solidFill>
+            <a:srgbClr val="FF7A18"/>
+          </a:solidFill>
+          <a:ln>
+            <a:noFill/>
+          </a:ln>
+          <a:effectLst/>
+        </p:spPr>
+        <p:style>
+          <a:lnRef idx="1">
+            <a:schemeClr val="accent1"/>
+          </a:lnRef>
+          <a:fillRef idx="3">
+            <a:schemeClr val="accent1"/>
+          </a:fillRef>
+          <a:effectRef idx="2">
+            <a:schemeClr val="accent1"/>
+          </a:effectRef>
+          <a:fontRef idx="minor">
+            <a:schemeClr val="lt1"/>
+          </a:fontRef>
+        </p:style>
+        <p:txBody>
+          <a:bodyPr rtlCol="0" anchor="ctr" wrap="square"/>
+          <a:lstStyle/>
+          <a:p>
+            <a:pPr algn="ctr"/>
+            <a:r>
+              <a:rPr sz="1600" b="1" u="none">
+                <a:solidFill>
+                  <a:srgbClr val="FFFFFF"/>
+                </a:solidFill>
+                <a:latin typeface="Calibri"/>
+              </a:rPr>
+              <a:t>4</a:t>
+            </a:r>
+          </a:p>
+        </p:txBody>
+      </p:sp>
+      <p:sp>
+        <p:nvSpPr>
+          <p:cNvPr id="14" name="TextBox 13"/>
+          <p:cNvSpPr txBox="1"/>
+          <p:nvPr/>
+        </p:nvSpPr>
+        <p:spPr>
+          <a:xfrm>
+            <a:off x="1097280" y="3104388"/>
+            <a:ext cx="2377440" cy="457200"/>
+          </a:xfrm>
+          <a:prstGeom prst="rect">
+            <a:avLst/>
+          </a:prstGeom>
+          <a:noFill/>
+        </p:spPr>
+        <p:txBody>
+          <a:bodyPr wrap="square" anchor="ctr" lIns="0" rIns="0" tIns="0" bIns="0">
+            <a:spAutoFit/>
+          </a:bodyPr>
+          <a:lstStyle/>
+          <a:p>
+            <a:r>
+              <a:rPr sz="1200" b="1" u="none">
                 <a:solidFill>
                   <a:srgbClr val="1A2C52"/>
                 </a:solidFill>
-                <a:latin typeface="Calibri" pitchFamily="34" charset="0"/>
-                <a:ea typeface="Calibri" pitchFamily="34" charset="-122"/>
-                <a:cs typeface="Calibri" pitchFamily="34" charset="-120"/>
-              </a:rPr>
-              <a:t>ciudades cubiertas</a:t>
-            </a:r>
-            <a:endParaRPr lang="en-US" sz="1050" dirty="0"/>
-          </a:p>
-          <a:p>
-            <a:pPr indent="0" marL="0">
-              <a:buNone/>
-            </a:pPr>
-            <a:r>
-              <a:rPr lang="en-US" sz="900" dirty="0">
-                <a:solidFill>
-                  <a:srgbClr val="475569"/>
-                </a:solidFill>
-                <a:latin typeface="Calibri" pitchFamily="34" charset="0"/>
-                <a:ea typeface="Calibri" pitchFamily="34" charset="-122"/>
-                <a:cs typeface="Calibri" pitchFamily="34" charset="-120"/>
-              </a:rPr>
-              <a:t>sin coste extra</a:t>
-            </a:r>
-            <a:endParaRPr lang="en-US" sz="1050" dirty="0"/>
-          </a:p>
-        </p:txBody>
-      </p:sp>
-      <p:sp>
-        <p:nvSpPr>
-          <p:cNvPr id="17" name="Text 14"/>
-          <p:cNvSpPr/>
+                <a:latin typeface="Calibri"/>
+              </a:rPr>
+              <a:t>Entra en Google y crea una App Password</a:t>
+            </a:r>
+          </a:p>
+        </p:txBody>
+      </p:sp>
+      <p:sp>
+        <p:nvSpPr>
+          <p:cNvPr id="15" name="TextBox 14"/>
+          <p:cNvSpPr txBox="1"/>
+          <p:nvPr/>
+        </p:nvSpPr>
+        <p:spPr>
+          <a:xfrm>
+            <a:off x="3566160" y="3104388"/>
+            <a:ext cx="5212080" cy="457200"/>
+          </a:xfrm>
+          <a:prstGeom prst="rect">
+            <a:avLst/>
+          </a:prstGeom>
+          <a:noFill/>
+        </p:spPr>
+        <p:txBody>
+          <a:bodyPr wrap="square" anchor="ctr" lIns="0" rIns="0" tIns="0" bIns="0">
+            <a:spAutoFit/>
+          </a:bodyPr>
+          <a:lstStyle/>
+          <a:p>
+            <a:r>
+              <a:rPr sz="1050" b="0" u="none">
+                <a:solidFill>
+                  <a:srgbClr val="0D1A36"/>
+                </a:solidFill>
+                <a:latin typeface="Calibri"/>
+              </a:rPr>
+              <a:t>Ve a </a:t>
+            </a:r>
+            <a:r>
+              <a:rPr sz="1050" b="0" u="sng">
+                <a:solidFill>
+                  <a:srgbClr val="C04A00"/>
+                </a:solidFill>
+                <a:latin typeface="Calibri"/>
+                <a:hlinkClick r:id="rId4"/>
+              </a:rPr>
+              <a:t>myaccount.google.com/apppasswords</a:t>
+            </a:r>
+            <a:r>
+              <a:rPr sz="1050" b="0" u="none">
+                <a:solidFill>
+                  <a:srgbClr val="0D1A36"/>
+                </a:solidFill>
+                <a:latin typeface="Calibri"/>
+              </a:rPr>
+              <a:t> y genera la clave de 16 dígitos (Gmail no admite tu contraseña normal).</a:t>
+            </a:r>
+          </a:p>
+        </p:txBody>
+      </p:sp>
+      <p:sp>
+        <p:nvSpPr>
+          <p:cNvPr id="16" name="Rounded Rectangle 15"/>
+          <p:cNvSpPr/>
+          <p:nvPr/>
+        </p:nvSpPr>
+        <p:spPr>
+          <a:xfrm>
+            <a:off x="457200" y="3666744"/>
+            <a:ext cx="457200" cy="457200"/>
+          </a:xfrm>
+          <a:prstGeom prst="roundRect">
+            <a:avLst/>
+          </a:prstGeom>
+          <a:solidFill>
+            <a:srgbClr val="FF7A18"/>
+          </a:solidFill>
+          <a:ln>
+            <a:noFill/>
+          </a:ln>
+          <a:effectLst/>
+        </p:spPr>
+        <p:style>
+          <a:lnRef idx="1">
+            <a:schemeClr val="accent1"/>
+          </a:lnRef>
+          <a:fillRef idx="3">
+            <a:schemeClr val="accent1"/>
+          </a:fillRef>
+          <a:effectRef idx="2">
+            <a:schemeClr val="accent1"/>
+          </a:effectRef>
+          <a:fontRef idx="minor">
+            <a:schemeClr val="lt1"/>
+          </a:fontRef>
+        </p:style>
+        <p:txBody>
+          <a:bodyPr rtlCol="0" anchor="ctr" wrap="square"/>
+          <a:lstStyle/>
+          <a:p>
+            <a:pPr algn="ctr"/>
+            <a:r>
+              <a:rPr sz="1600" b="1" u="none">
+                <a:solidFill>
+                  <a:srgbClr val="FFFFFF"/>
+                </a:solidFill>
+                <a:latin typeface="Calibri"/>
+              </a:rPr>
+              <a:t>5</a:t>
+            </a:r>
+          </a:p>
+        </p:txBody>
+      </p:sp>
+      <p:sp>
+        <p:nvSpPr>
+          <p:cNvPr id="17" name="TextBox 16"/>
+          <p:cNvSpPr txBox="1"/>
+          <p:nvPr/>
+        </p:nvSpPr>
+        <p:spPr>
+          <a:xfrm>
+            <a:off x="1097280" y="3666744"/>
+            <a:ext cx="2377440" cy="457200"/>
+          </a:xfrm>
+          <a:prstGeom prst="rect">
+            <a:avLst/>
+          </a:prstGeom>
+          <a:noFill/>
+        </p:spPr>
+        <p:txBody>
+          <a:bodyPr wrap="square" anchor="ctr" lIns="0" rIns="0" tIns="0" bIns="0">
+            <a:spAutoFit/>
+          </a:bodyPr>
+          <a:lstStyle/>
+          <a:p>
+            <a:r>
+              <a:rPr sz="1200" b="1" u="none">
+                <a:solidFill>
+                  <a:srgbClr val="1A2C52"/>
+                </a:solidFill>
+                <a:latin typeface="Calibri"/>
+              </a:rPr>
+              <a:t>Configura el envío por email (opcional)</a:t>
+            </a:r>
+          </a:p>
+        </p:txBody>
+      </p:sp>
+      <p:sp>
+        <p:nvSpPr>
+          <p:cNvPr id="18" name="TextBox 17"/>
+          <p:cNvSpPr txBox="1"/>
+          <p:nvPr/>
+        </p:nvSpPr>
+        <p:spPr>
+          <a:xfrm>
+            <a:off x="3566160" y="3666744"/>
+            <a:ext cx="5212080" cy="457200"/>
+          </a:xfrm>
+          <a:prstGeom prst="rect">
+            <a:avLst/>
+          </a:prstGeom>
+          <a:noFill/>
+        </p:spPr>
+        <p:txBody>
+          <a:bodyPr wrap="square" anchor="ctr" lIns="0" rIns="0" tIns="0" bIns="0">
+            <a:spAutoFit/>
+          </a:bodyPr>
+          <a:lstStyle/>
+          <a:p>
+            <a:r>
+              <a:rPr sz="1050" b="0" u="none">
+                <a:solidFill>
+                  <a:srgbClr val="0D1A36"/>
+                </a:solidFill>
+                <a:latin typeface="Calibri"/>
+              </a:rPr>
+              <a:t>smtp.gmail.com · puerto 587 · tu email · la App Password · el destinatario.</a:t>
+            </a:r>
+          </a:p>
+        </p:txBody>
+      </p:sp>
+      <p:sp>
+        <p:nvSpPr>
+          <p:cNvPr id="19" name="Rounded Rectangle 18"/>
+          <p:cNvSpPr/>
+          <p:nvPr/>
+        </p:nvSpPr>
+        <p:spPr>
+          <a:xfrm>
+            <a:off x="457200" y="4229100"/>
+            <a:ext cx="457200" cy="457200"/>
+          </a:xfrm>
+          <a:prstGeom prst="roundRect">
+            <a:avLst/>
+          </a:prstGeom>
+          <a:solidFill>
+            <a:srgbClr val="FF7A18"/>
+          </a:solidFill>
+          <a:ln>
+            <a:noFill/>
+          </a:ln>
+          <a:effectLst/>
+        </p:spPr>
+        <p:style>
+          <a:lnRef idx="1">
+            <a:schemeClr val="accent1"/>
+          </a:lnRef>
+          <a:fillRef idx="3">
+            <a:schemeClr val="accent1"/>
+          </a:fillRef>
+          <a:effectRef idx="2">
+            <a:schemeClr val="accent1"/>
+          </a:effectRef>
+          <a:fontRef idx="minor">
+            <a:schemeClr val="lt1"/>
+          </a:fontRef>
+        </p:style>
+        <p:txBody>
+          <a:bodyPr rtlCol="0" anchor="ctr" wrap="square"/>
+          <a:lstStyle/>
+          <a:p>
+            <a:pPr algn="ctr"/>
+            <a:r>
+              <a:rPr sz="1600" b="1" u="none">
+                <a:solidFill>
+                  <a:srgbClr val="FFFFFF"/>
+                </a:solidFill>
+                <a:latin typeface="Calibri"/>
+              </a:rPr>
+              <a:t>6</a:t>
+            </a:r>
+          </a:p>
+        </p:txBody>
+      </p:sp>
+      <p:sp>
+        <p:nvSpPr>
+          <p:cNvPr id="20" name="TextBox 19"/>
+          <p:cNvSpPr txBox="1"/>
+          <p:nvPr/>
+        </p:nvSpPr>
+        <p:spPr>
+          <a:xfrm>
+            <a:off x="1097280" y="4229100"/>
+            <a:ext cx="2377440" cy="457200"/>
+          </a:xfrm>
+          <a:prstGeom prst="rect">
+            <a:avLst/>
+          </a:prstGeom>
+          <a:noFill/>
+        </p:spPr>
+        <p:txBody>
+          <a:bodyPr wrap="square" anchor="ctr" lIns="0" rIns="0" tIns="0" bIns="0">
+            <a:spAutoFit/>
+          </a:bodyPr>
+          <a:lstStyle/>
+          <a:p>
+            <a:r>
+              <a:rPr sz="1200" b="1" u="none">
+                <a:solidFill>
+                  <a:srgbClr val="1A2C52"/>
+                </a:solidFill>
+                <a:latin typeface="Calibri"/>
+              </a:rPr>
+              <a:t>Pulsa «Lanzar informe»</a:t>
+            </a:r>
+          </a:p>
+        </p:txBody>
+      </p:sp>
+      <p:sp>
+        <p:nvSpPr>
+          <p:cNvPr id="21" name="TextBox 20"/>
+          <p:cNvSpPr txBox="1"/>
+          <p:nvPr/>
+        </p:nvSpPr>
+        <p:spPr>
+          <a:xfrm>
+            <a:off x="3566160" y="4229100"/>
+            <a:ext cx="5212080" cy="457200"/>
+          </a:xfrm>
+          <a:prstGeom prst="rect">
+            <a:avLst/>
+          </a:prstGeom>
+          <a:noFill/>
+        </p:spPr>
+        <p:txBody>
+          <a:bodyPr wrap="square" anchor="ctr" lIns="0" rIns="0" tIns="0" bIns="0">
+            <a:spAutoFit/>
+          </a:bodyPr>
+          <a:lstStyle/>
+          <a:p>
+            <a:r>
+              <a:rPr sz="1050" b="0" u="none">
+                <a:solidFill>
+                  <a:srgbClr val="0D1A36"/>
+                </a:solidFill>
+                <a:latin typeface="Calibri"/>
+              </a:rPr>
+              <a:t>Se genera el Excel, se descarga en pantalla y llega por email si configuraste SMTP.</a:t>
+            </a:r>
+          </a:p>
+        </p:txBody>
+      </p:sp>
+      <p:sp>
+        <p:nvSpPr>
+          <p:cNvPr id="22" name="TextBox 21"/>
+          <p:cNvSpPr txBox="1"/>
           <p:nvPr/>
         </p:nvSpPr>
         <p:spPr>
@@ -12481,34 +13821,29 @@
             <a:avLst/>
           </a:prstGeom>
           <a:noFill/>
-          <a:ln/>
-        </p:spPr>
-        <p:txBody>
-          <a:bodyPr wrap="square" rtlCol="0" anchor="ctr"/>
-          <a:lstStyle/>
-          <a:p>
-            <a:pPr indent="0" marL="0">
-              <a:buNone/>
-            </a:pPr>
-            <a:r>
-              <a:rPr lang="en-US" sz="900" dirty="0">
+        </p:spPr>
+        <p:txBody>
+          <a:bodyPr wrap="square" anchor="t" lIns="0" rIns="0" tIns="0" bIns="0">
+            <a:spAutoFit/>
+          </a:bodyPr>
+          <a:lstStyle/>
+          <a:p>
+            <a:r>
+              <a:rPr sz="900" b="0" u="none">
                 <a:solidFill>
                   <a:srgbClr val="475569"/>
                 </a:solidFill>
-                <a:latin typeface="Calibri" pitchFamily="34" charset="0"/>
-                <a:ea typeface="Calibri" pitchFamily="34" charset="-122"/>
-                <a:cs typeface="Calibri" pitchFamily="34" charset="-120"/>
-              </a:rPr>
-              <a:t>Hibrusi · Automatización · Proyecto Nebrija</a:t>
-            </a:r>
-            <a:endParaRPr lang="en-US" sz="900" dirty="0"/>
-          </a:p>
-        </p:txBody>
-      </p:sp>
-      <p:sp>
-        <p:nvSpPr>
-          <p:cNvPr id="18" name="Text 15"/>
-          <p:cNvSpPr/>
+                <a:latin typeface="Calibri"/>
+              </a:rPr>
+              <a:t>Javier, David y Bruno · Automatización · Proyecto Nebrija</a:t>
+            </a:r>
+          </a:p>
+        </p:txBody>
+      </p:sp>
+      <p:sp>
+        <p:nvSpPr>
+          <p:cNvPr id="23" name="TextBox 22"/>
+          <p:cNvSpPr txBox="1"/>
           <p:nvPr/>
         </p:nvSpPr>
         <p:spPr>
@@ -12520,27 +13855,23 @@
             <a:avLst/>
           </a:prstGeom>
           <a:noFill/>
-          <a:ln/>
-        </p:spPr>
-        <p:txBody>
-          <a:bodyPr wrap="square" rtlCol="0" anchor="ctr"/>
-          <a:lstStyle/>
-          <a:p>
-            <a:pPr algn="r" indent="0" marL="0">
-              <a:buNone/>
-            </a:pPr>
-            <a:r>
-              <a:rPr lang="en-US" sz="900" dirty="0">
+        </p:spPr>
+        <p:txBody>
+          <a:bodyPr wrap="square" anchor="t" lIns="0" rIns="0" tIns="0" bIns="0">
+            <a:spAutoFit/>
+          </a:bodyPr>
+          <a:lstStyle/>
+          <a:p>
+            <a:pPr algn="r"/>
+            <a:r>
+              <a:rPr sz="900" b="0" u="none">
                 <a:solidFill>
                   <a:srgbClr val="475569"/>
                 </a:solidFill>
-                <a:latin typeface="Calibri" pitchFamily="34" charset="0"/>
-                <a:ea typeface="Calibri" pitchFamily="34" charset="-122"/>
-                <a:cs typeface="Calibri" pitchFamily="34" charset="-120"/>
+                <a:latin typeface="Calibri"/>
               </a:rPr>
               <a:t>9</a:t>
             </a:r>
-            <a:endParaRPr lang="en-US" sz="900" dirty="0"/>
           </a:p>
         </p:txBody>
       </p:sp>

</xml_diff>